<commit_message>
docs: expand walkthrough and slide deck with per-component explanations
</commit_message>
<xml_diff>
--- a/docs/Fabric-as-Code.pptx
+++ b/docs/Fabric-as-Code.pptx
@@ -16,6 +16,9 @@
     <p:sldId id="264" r:id="rId15"/>
     <p:sldId id="265" r:id="rId16"/>
     <p:sldId id="266" r:id="rId17"/>
+    <p:sldId id="267" r:id="rId18"/>
+    <p:sldId id="268" r:id="rId19"/>
+    <p:sldId id="269" r:id="rId20"/>
   </p:sldIdLst>
   <p:sldSz cx="12191695" cy="6858000" type="screen4x3"/>
   <p:notesSz cx="6858000" cy="9144000"/>
@@ -3271,7 +3274,7 @@
         <p:spPr>
           <a:xfrm>
             <a:off x="0" y="0"/>
-            <a:ext cx="12191695" cy="1005840"/>
+            <a:ext cx="12191695" cy="914400"/>
           </a:xfrm>
           <a:prstGeom prst="rect">
             <a:avLst/>
@@ -3314,8 +3317,8 @@
         </p:nvSpPr>
         <p:spPr>
           <a:xfrm>
-            <a:off x="548640" y="164592"/>
-            <a:ext cx="10972800" cy="731520"/>
+            <a:off x="548640" y="109728"/>
+            <a:ext cx="11064240" cy="694944"/>
           </a:xfrm>
           <a:prstGeom prst="rect">
             <a:avLst/>
@@ -3330,12 +3333,12 @@
           <a:p>
             <a:pPr algn="l"/>
             <a:r>
-              <a:rPr sz="3000" b="1">
+              <a:rPr sz="2800" b="1">
                 <a:solidFill>
                   <a:srgbClr val="FFFFFF"/>
                 </a:solidFill>
               </a:rPr>
-              <a:t>What you can build on this</a:t>
+              <a:t>Fabric — Notebook</a:t>
             </a:r>
           </a:p>
         </p:txBody>
@@ -3348,8 +3351,8 @@
         </p:nvSpPr>
         <p:spPr>
           <a:xfrm>
-            <a:off x="731520" y="1371600"/>
-            <a:ext cx="10698480" cy="4937760"/>
+            <a:off x="548640" y="1024128"/>
+            <a:ext cx="11064240" cy="731520"/>
           </a:xfrm>
           <a:prstGeom prst="rect">
             <a:avLst/>
@@ -3357,87 +3360,47 @@
           <a:noFill/>
         </p:spPr>
         <p:txBody>
-          <a:bodyPr wrap="square">
+          <a:bodyPr wrap="square" anchor="t">
             <a:spAutoFit/>
           </a:bodyPr>
           <a:lstStyle/>
           <a:p>
-            <a:pPr>
-              <a:spcAft>
-                <a:spcPts val="800"/>
-              </a:spcAft>
-            </a:pPr>
-            <a:r>
-              <a:rPr sz="2200">
-                <a:solidFill>
-                  <a:srgbClr val="202020"/>
+            <a:pPr algn="l"/>
+            <a:r>
+              <a:rPr sz="1500" b="0">
+                <a:solidFill>
+                  <a:srgbClr val="555555"/>
                 </a:solidFill>
               </a:rPr>
-              <a:t>• Medallion data platform — Lakehouse (bronze/silver/gold) + Spark notebooks</a:t>
-            </a:r>
-          </a:p>
-          <a:p>
-            <a:pPr>
-              <a:spcAft>
-                <a:spcPts val="800"/>
-              </a:spcAft>
-            </a:pPr>
-            <a:r>
-              <a:rPr sz="2200">
-                <a:solidFill>
-                  <a:srgbClr val="202020"/>
-                </a:solidFill>
-              </a:rPr>
-              <a:t>• SQL warehousing — Warehouse with versioned schema, tables &amp; stored procedures</a:t>
-            </a:r>
-          </a:p>
-          <a:p>
-            <a:pPr>
-              <a:spcAft>
-                <a:spcPts val="800"/>
-              </a:spcAft>
-            </a:pPr>
-            <a:r>
-              <a:rPr sz="2200">
-                <a:solidFill>
-                  <a:srgbClr val="202020"/>
-                </a:solidFill>
-              </a:rPr>
-              <a:t>• Orchestration — Data Pipelines chaining notebooks, copies &amp; procs</a:t>
-            </a:r>
-          </a:p>
-          <a:p>
-            <a:pPr>
-              <a:spcAft>
-                <a:spcPts val="800"/>
-              </a:spcAft>
-            </a:pPr>
-            <a:r>
-              <a:rPr sz="2200">
-                <a:solidFill>
-                  <a:srgbClr val="202020"/>
-                </a:solidFill>
-              </a:rPr>
-              <a:t>• Promotion — Git integration + deployment pipelines (dev → test → prod)</a:t>
-            </a:r>
-          </a:p>
-          <a:p>
-            <a:pPr>
-              <a:spcAft>
-                <a:spcPts val="800"/>
-              </a:spcAft>
-            </a:pPr>
-            <a:r>
-              <a:rPr sz="2200">
-                <a:solidFill>
-                  <a:srgbClr val="202020"/>
-                </a:solidFill>
-              </a:rPr>
-              <a:t>• Governance as code — capacity sizing, admins and RBAC in source control</a:t>
-            </a:r>
-          </a:p>
-        </p:txBody>
-      </p:sp>
+              <a:t>nb_demo_load: PySpark builds the dataset and saveAsTable writes it to the attached Lakehouse. The Lakehouse binding is injected at deploy time.</a:t>
+            </a:r>
+          </a:p>
+        </p:txBody>
+      </p:sp>
+      <p:pic>
+        <p:nvPicPr>
+          <p:cNvPr id="5" name="Picture 4" descr="03-notebook.png"/>
+          <p:cNvPicPr>
+            <a:picLocks noChangeAspect="1"/>
+          </p:cNvPicPr>
+          <p:nvPr/>
+        </p:nvPicPr>
+        <p:blipFill>
+          <a:blip r:embed="rId2"/>
+          <a:stretch>
+            <a:fillRect/>
+          </a:stretch>
+        </p:blipFill>
+        <p:spPr>
+          <a:xfrm>
+            <a:off x="548640" y="1828800"/>
+            <a:ext cx="8193511" cy="4480560"/>
+          </a:xfrm>
+          <a:prstGeom prst="rect">
+            <a:avLst/>
+          </a:prstGeom>
+        </p:spPr>
+      </p:pic>
     </p:spTree>
   </p:cSld>
   <p:clrMapOvr>
@@ -3465,7 +3428,7 @@
         <p:spPr>
           <a:xfrm>
             <a:off x="0" y="0"/>
-            <a:ext cx="12191695" cy="1005840"/>
+            <a:ext cx="12191695" cy="914400"/>
           </a:xfrm>
           <a:prstGeom prst="rect">
             <a:avLst/>
@@ -3508,8 +3471,8 @@
         </p:nvSpPr>
         <p:spPr>
           <a:xfrm>
-            <a:off x="548640" y="164592"/>
-            <a:ext cx="10972800" cy="731520"/>
+            <a:off x="548640" y="109728"/>
+            <a:ext cx="11064240" cy="694944"/>
           </a:xfrm>
           <a:prstGeom prst="rect">
             <a:avLst/>
@@ -3524,12 +3487,12 @@
           <a:p>
             <a:pPr algn="l"/>
             <a:r>
-              <a:rPr sz="3000" b="1">
+              <a:rPr sz="2800" b="1">
                 <a:solidFill>
                   <a:srgbClr val="FFFFFF"/>
                 </a:solidFill>
               </a:rPr>
-              <a:t>Get started</a:t>
+              <a:t>Fabric — Data Pipeline</a:t>
             </a:r>
           </a:p>
         </p:txBody>
@@ -3542,8 +3505,8 @@
         </p:nvSpPr>
         <p:spPr>
           <a:xfrm>
-            <a:off x="731520" y="1371600"/>
-            <a:ext cx="10698480" cy="4937760"/>
+            <a:off x="548640" y="1024128"/>
+            <a:ext cx="11064240" cy="731520"/>
           </a:xfrm>
           <a:prstGeom prst="rect">
             <a:avLst/>
@@ -3551,6 +3514,338 @@
           <a:noFill/>
         </p:spPr>
         <p:txBody>
+          <a:bodyPr wrap="square" anchor="t">
+            <a:spAutoFit/>
+          </a:bodyPr>
+          <a:lstStyle/>
+          <a:p>
+            <a:pPr algn="l"/>
+            <a:r>
+              <a:rPr sz="1500" b="0">
+                <a:solidFill>
+                  <a:srgbClr val="555555"/>
+                </a:solidFill>
+              </a:rPr>
+              <a:t>Design: Wait → Run Notebook (success dependency). Run: Succeeded. Orchestration that executed the notebook and populated the Delta table.</a:t>
+            </a:r>
+          </a:p>
+        </p:txBody>
+      </p:sp>
+      <p:pic>
+        <p:nvPicPr>
+          <p:cNvPr id="5" name="Picture 4" descr="04-pipeline-canvas.png"/>
+          <p:cNvPicPr>
+            <a:picLocks noChangeAspect="1"/>
+          </p:cNvPicPr>
+          <p:nvPr/>
+        </p:nvPicPr>
+        <p:blipFill>
+          <a:blip r:embed="rId2"/>
+          <a:stretch>
+            <a:fillRect/>
+          </a:stretch>
+        </p:blipFill>
+        <p:spPr>
+          <a:xfrm>
+            <a:off x="548640" y="2430770"/>
+            <a:ext cx="5410047" cy="3276620"/>
+          </a:xfrm>
+          <a:prstGeom prst="rect">
+            <a:avLst/>
+          </a:prstGeom>
+        </p:spPr>
+      </p:pic>
+      <p:pic>
+        <p:nvPicPr>
+          <p:cNvPr id="6" name="Picture 5" descr="05-pipeline-run.png"/>
+          <p:cNvPicPr>
+            <a:picLocks noChangeAspect="1"/>
+          </p:cNvPicPr>
+          <p:nvPr/>
+        </p:nvPicPr>
+        <p:blipFill>
+          <a:blip r:embed="rId3"/>
+          <a:stretch>
+            <a:fillRect/>
+          </a:stretch>
+        </p:blipFill>
+        <p:spPr>
+          <a:xfrm>
+            <a:off x="6233007" y="3484842"/>
+            <a:ext cx="5410047" cy="1168476"/>
+          </a:xfrm>
+          <a:prstGeom prst="rect">
+            <a:avLst/>
+          </a:prstGeom>
+        </p:spPr>
+      </p:pic>
+    </p:spTree>
+  </p:cSld>
+  <p:clrMapOvr>
+    <a:masterClrMapping/>
+  </p:clrMapOvr>
+</p:sld>
+</file>
+
+<file path=ppt/slides/slide12.xml><?xml version="1.0" encoding="utf-8"?>
+<p:sld xmlns:a="http://schemas.openxmlformats.org/drawingml/2006/main" xmlns:p="http://schemas.openxmlformats.org/presentationml/2006/main" xmlns:r="http://schemas.openxmlformats.org/officeDocument/2006/relationships">
+  <p:cSld>
+    <p:spTree>
+      <p:nvGrpSpPr>
+        <p:cNvPr id="1" name=""/>
+        <p:cNvGrpSpPr/>
+        <p:nvPr/>
+      </p:nvGrpSpPr>
+      <p:grpSpPr/>
+      <p:sp>
+        <p:nvSpPr>
+          <p:cNvPr id="2" name="Rectangle 1"/>
+          <p:cNvSpPr/>
+          <p:nvPr/>
+        </p:nvSpPr>
+        <p:spPr>
+          <a:xfrm>
+            <a:off x="0" y="0"/>
+            <a:ext cx="12191695" cy="914400"/>
+          </a:xfrm>
+          <a:prstGeom prst="rect">
+            <a:avLst/>
+          </a:prstGeom>
+          <a:solidFill>
+            <a:srgbClr val="117365"/>
+          </a:solidFill>
+          <a:ln>
+            <a:noFill/>
+          </a:ln>
+          <a:effectLst/>
+        </p:spPr>
+        <p:style>
+          <a:lnRef idx="1">
+            <a:schemeClr val="accent1"/>
+          </a:lnRef>
+          <a:fillRef idx="3">
+            <a:schemeClr val="accent1"/>
+          </a:fillRef>
+          <a:effectRef idx="2">
+            <a:schemeClr val="accent1"/>
+          </a:effectRef>
+          <a:fontRef idx="minor">
+            <a:schemeClr val="lt1"/>
+          </a:fontRef>
+        </p:style>
+        <p:txBody>
+          <a:bodyPr rtlCol="0" anchor="ctr"/>
+          <a:lstStyle/>
+          <a:p>
+            <a:pPr algn="ctr"/>
+          </a:p>
+        </p:txBody>
+      </p:sp>
+      <p:sp>
+        <p:nvSpPr>
+          <p:cNvPr id="3" name="TextBox 2"/>
+          <p:cNvSpPr txBox="1"/>
+          <p:nvPr/>
+        </p:nvSpPr>
+        <p:spPr>
+          <a:xfrm>
+            <a:off x="548640" y="109728"/>
+            <a:ext cx="11064240" cy="694944"/>
+          </a:xfrm>
+          <a:prstGeom prst="rect">
+            <a:avLst/>
+          </a:prstGeom>
+          <a:noFill/>
+        </p:spPr>
+        <p:txBody>
+          <a:bodyPr wrap="square" anchor="ctr">
+            <a:spAutoFit/>
+          </a:bodyPr>
+          <a:lstStyle/>
+          <a:p>
+            <a:pPr algn="l"/>
+            <a:r>
+              <a:rPr sz="2800" b="1">
+                <a:solidFill>
+                  <a:srgbClr val="FFFFFF"/>
+                </a:solidFill>
+              </a:rPr>
+              <a:t>Azure — Fabric capacity</a:t>
+            </a:r>
+          </a:p>
+        </p:txBody>
+      </p:sp>
+      <p:sp>
+        <p:nvSpPr>
+          <p:cNvPr id="4" name="TextBox 3"/>
+          <p:cNvSpPr txBox="1"/>
+          <p:nvPr/>
+        </p:nvSpPr>
+        <p:spPr>
+          <a:xfrm>
+            <a:off x="548640" y="1024128"/>
+            <a:ext cx="11064240" cy="731520"/>
+          </a:xfrm>
+          <a:prstGeom prst="rect">
+            <a:avLst/>
+          </a:prstGeom>
+          <a:noFill/>
+        </p:spPr>
+        <p:txBody>
+          <a:bodyPr wrap="square" anchor="t">
+            <a:spAutoFit/>
+          </a:bodyPr>
+          <a:lstStyle/>
+          <a:p>
+            <a:pPr algn="l"/>
+            <a:r>
+              <a:rPr sz="1500" b="0">
+                <a:solidFill>
+                  <a:srgbClr val="555555"/>
+                </a:solidFill>
+              </a:rPr>
+              <a:t>The billable Microsoft.Fabric/capacities resource (F2) — the compute all items run on. Deployed by Bicep; pause to stop hourly billing.</a:t>
+            </a:r>
+          </a:p>
+        </p:txBody>
+      </p:sp>
+      <p:pic>
+        <p:nvPicPr>
+          <p:cNvPr id="5" name="Picture 4" descr="06-azure-capacity.png"/>
+          <p:cNvPicPr>
+            <a:picLocks noChangeAspect="1"/>
+          </p:cNvPicPr>
+          <p:nvPr/>
+        </p:nvPicPr>
+        <p:blipFill>
+          <a:blip r:embed="rId2"/>
+          <a:stretch>
+            <a:fillRect/>
+          </a:stretch>
+        </p:blipFill>
+        <p:spPr>
+          <a:xfrm>
+            <a:off x="548640" y="3336686"/>
+            <a:ext cx="11094415" cy="1464788"/>
+          </a:xfrm>
+          <a:prstGeom prst="rect">
+            <a:avLst/>
+          </a:prstGeom>
+        </p:spPr>
+      </p:pic>
+    </p:spTree>
+  </p:cSld>
+  <p:clrMapOvr>
+    <a:masterClrMapping/>
+  </p:clrMapOvr>
+</p:sld>
+</file>
+
+<file path=ppt/slides/slide13.xml><?xml version="1.0" encoding="utf-8"?>
+<p:sld xmlns:a="http://schemas.openxmlformats.org/drawingml/2006/main" xmlns:p="http://schemas.openxmlformats.org/presentationml/2006/main" xmlns:r="http://schemas.openxmlformats.org/officeDocument/2006/relationships">
+  <p:cSld>
+    <p:spTree>
+      <p:nvGrpSpPr>
+        <p:cNvPr id="1" name=""/>
+        <p:cNvGrpSpPr/>
+        <p:nvPr/>
+      </p:nvGrpSpPr>
+      <p:grpSpPr/>
+      <p:sp>
+        <p:nvSpPr>
+          <p:cNvPr id="2" name="Rectangle 1"/>
+          <p:cNvSpPr/>
+          <p:nvPr/>
+        </p:nvSpPr>
+        <p:spPr>
+          <a:xfrm>
+            <a:off x="0" y="0"/>
+            <a:ext cx="12191695" cy="914400"/>
+          </a:xfrm>
+          <a:prstGeom prst="rect">
+            <a:avLst/>
+          </a:prstGeom>
+          <a:solidFill>
+            <a:srgbClr val="117365"/>
+          </a:solidFill>
+          <a:ln>
+            <a:noFill/>
+          </a:ln>
+          <a:effectLst/>
+        </p:spPr>
+        <p:style>
+          <a:lnRef idx="1">
+            <a:schemeClr val="accent1"/>
+          </a:lnRef>
+          <a:fillRef idx="3">
+            <a:schemeClr val="accent1"/>
+          </a:fillRef>
+          <a:effectRef idx="2">
+            <a:schemeClr val="accent1"/>
+          </a:effectRef>
+          <a:fontRef idx="minor">
+            <a:schemeClr val="lt1"/>
+          </a:fontRef>
+        </p:style>
+        <p:txBody>
+          <a:bodyPr rtlCol="0" anchor="ctr"/>
+          <a:lstStyle/>
+          <a:p>
+            <a:pPr algn="ctr"/>
+          </a:p>
+        </p:txBody>
+      </p:sp>
+      <p:sp>
+        <p:nvSpPr>
+          <p:cNvPr id="3" name="TextBox 2"/>
+          <p:cNvSpPr txBox="1"/>
+          <p:nvPr/>
+        </p:nvSpPr>
+        <p:spPr>
+          <a:xfrm>
+            <a:off x="548640" y="109728"/>
+            <a:ext cx="11064240" cy="694944"/>
+          </a:xfrm>
+          <a:prstGeom prst="rect">
+            <a:avLst/>
+          </a:prstGeom>
+          <a:noFill/>
+        </p:spPr>
+        <p:txBody>
+          <a:bodyPr wrap="square" anchor="ctr">
+            <a:spAutoFit/>
+          </a:bodyPr>
+          <a:lstStyle/>
+          <a:p>
+            <a:pPr algn="l"/>
+            <a:r>
+              <a:rPr sz="2800" b="1">
+                <a:solidFill>
+                  <a:srgbClr val="FFFFFF"/>
+                </a:solidFill>
+              </a:rPr>
+              <a:t>What you can build on this</a:t>
+            </a:r>
+          </a:p>
+        </p:txBody>
+      </p:sp>
+      <p:sp>
+        <p:nvSpPr>
+          <p:cNvPr id="4" name="TextBox 3"/>
+          <p:cNvSpPr txBox="1"/>
+          <p:nvPr/>
+        </p:nvSpPr>
+        <p:spPr>
+          <a:xfrm>
+            <a:off x="731520" y="1280160"/>
+            <a:ext cx="10698480" cy="5120640"/>
+          </a:xfrm>
+          <a:prstGeom prst="rect">
+            <a:avLst/>
+          </a:prstGeom>
+          <a:noFill/>
+        </p:spPr>
+        <p:txBody>
           <a:bodyPr wrap="square">
             <a:spAutoFit/>
           </a:bodyPr>
@@ -3558,11 +3853,205 @@
           <a:p>
             <a:pPr>
               <a:spcAft>
-                <a:spcPts val="800"/>
+                <a:spcPts val="700"/>
               </a:spcAft>
             </a:pPr>
             <a:r>
-              <a:rPr sz="2200">
+              <a:rPr sz="2100">
+                <a:solidFill>
+                  <a:srgbClr val="202020"/>
+                </a:solidFill>
+              </a:rPr>
+              <a:t>• Medallion platform — Lakehouse bronze/silver/gold + Spark notebooks</a:t>
+            </a:r>
+          </a:p>
+          <a:p>
+            <a:pPr>
+              <a:spcAft>
+                <a:spcPts val="700"/>
+              </a:spcAft>
+            </a:pPr>
+            <a:r>
+              <a:rPr sz="2100">
+                <a:solidFill>
+                  <a:srgbClr val="202020"/>
+                </a:solidFill>
+              </a:rPr>
+              <a:t>• SQL warehousing — Warehouse with versioned schema, tables &amp; stored procedures</a:t>
+            </a:r>
+          </a:p>
+          <a:p>
+            <a:pPr>
+              <a:spcAft>
+                <a:spcPts val="700"/>
+              </a:spcAft>
+            </a:pPr>
+            <a:r>
+              <a:rPr sz="2100">
+                <a:solidFill>
+                  <a:srgbClr val="202020"/>
+                </a:solidFill>
+              </a:rPr>
+              <a:t>• Orchestration — Pipelines chaining notebooks, copies &amp; procedures</a:t>
+            </a:r>
+          </a:p>
+          <a:p>
+            <a:pPr>
+              <a:spcAft>
+                <a:spcPts val="700"/>
+              </a:spcAft>
+            </a:pPr>
+            <a:r>
+              <a:rPr sz="2100">
+                <a:solidFill>
+                  <a:srgbClr val="202020"/>
+                </a:solidFill>
+              </a:rPr>
+              <a:t>• Promotion — Git integration + deployment pipelines (dev → test → prod)</a:t>
+            </a:r>
+          </a:p>
+          <a:p>
+            <a:pPr>
+              <a:spcAft>
+                <a:spcPts val="700"/>
+              </a:spcAft>
+            </a:pPr>
+            <a:r>
+              <a:rPr sz="2100">
+                <a:solidFill>
+                  <a:srgbClr val="202020"/>
+                </a:solidFill>
+              </a:rPr>
+              <a:t>• Governance as code — capacity sizing, admins &amp; RBAC in source control</a:t>
+            </a:r>
+          </a:p>
+        </p:txBody>
+      </p:sp>
+    </p:spTree>
+  </p:cSld>
+  <p:clrMapOvr>
+    <a:masterClrMapping/>
+  </p:clrMapOvr>
+</p:sld>
+</file>
+
+<file path=ppt/slides/slide14.xml><?xml version="1.0" encoding="utf-8"?>
+<p:sld xmlns:a="http://schemas.openxmlformats.org/drawingml/2006/main" xmlns:p="http://schemas.openxmlformats.org/presentationml/2006/main" xmlns:r="http://schemas.openxmlformats.org/officeDocument/2006/relationships">
+  <p:cSld>
+    <p:spTree>
+      <p:nvGrpSpPr>
+        <p:cNvPr id="1" name=""/>
+        <p:cNvGrpSpPr/>
+        <p:nvPr/>
+      </p:nvGrpSpPr>
+      <p:grpSpPr/>
+      <p:sp>
+        <p:nvSpPr>
+          <p:cNvPr id="2" name="Rectangle 1"/>
+          <p:cNvSpPr/>
+          <p:nvPr/>
+        </p:nvSpPr>
+        <p:spPr>
+          <a:xfrm>
+            <a:off x="0" y="0"/>
+            <a:ext cx="12191695" cy="914400"/>
+          </a:xfrm>
+          <a:prstGeom prst="rect">
+            <a:avLst/>
+          </a:prstGeom>
+          <a:solidFill>
+            <a:srgbClr val="117365"/>
+          </a:solidFill>
+          <a:ln>
+            <a:noFill/>
+          </a:ln>
+          <a:effectLst/>
+        </p:spPr>
+        <p:style>
+          <a:lnRef idx="1">
+            <a:schemeClr val="accent1"/>
+          </a:lnRef>
+          <a:fillRef idx="3">
+            <a:schemeClr val="accent1"/>
+          </a:fillRef>
+          <a:effectRef idx="2">
+            <a:schemeClr val="accent1"/>
+          </a:effectRef>
+          <a:fontRef idx="minor">
+            <a:schemeClr val="lt1"/>
+          </a:fontRef>
+        </p:style>
+        <p:txBody>
+          <a:bodyPr rtlCol="0" anchor="ctr"/>
+          <a:lstStyle/>
+          <a:p>
+            <a:pPr algn="ctr"/>
+          </a:p>
+        </p:txBody>
+      </p:sp>
+      <p:sp>
+        <p:nvSpPr>
+          <p:cNvPr id="3" name="TextBox 2"/>
+          <p:cNvSpPr txBox="1"/>
+          <p:nvPr/>
+        </p:nvSpPr>
+        <p:spPr>
+          <a:xfrm>
+            <a:off x="548640" y="109728"/>
+            <a:ext cx="11064240" cy="694944"/>
+          </a:xfrm>
+          <a:prstGeom prst="rect">
+            <a:avLst/>
+          </a:prstGeom>
+          <a:noFill/>
+        </p:spPr>
+        <p:txBody>
+          <a:bodyPr wrap="square" anchor="ctr">
+            <a:spAutoFit/>
+          </a:bodyPr>
+          <a:lstStyle/>
+          <a:p>
+            <a:pPr algn="l"/>
+            <a:r>
+              <a:rPr sz="2800" b="1">
+                <a:solidFill>
+                  <a:srgbClr val="FFFFFF"/>
+                </a:solidFill>
+              </a:rPr>
+              <a:t>Get started</a:t>
+            </a:r>
+          </a:p>
+        </p:txBody>
+      </p:sp>
+      <p:sp>
+        <p:nvSpPr>
+          <p:cNvPr id="4" name="TextBox 3"/>
+          <p:cNvSpPr txBox="1"/>
+          <p:nvPr/>
+        </p:nvSpPr>
+        <p:spPr>
+          <a:xfrm>
+            <a:off x="731520" y="1280160"/>
+            <a:ext cx="10698480" cy="5120640"/>
+          </a:xfrm>
+          <a:prstGeom prst="rect">
+            <a:avLst/>
+          </a:prstGeom>
+          <a:noFill/>
+        </p:spPr>
+        <p:txBody>
+          <a:bodyPr wrap="square">
+            <a:spAutoFit/>
+          </a:bodyPr>
+          <a:lstStyle/>
+          <a:p>
+            <a:pPr>
+              <a:spcAft>
+                <a:spcPts val="700"/>
+              </a:spcAft>
+            </a:pPr>
+            <a:r>
+              <a:rPr sz="2100">
                 <a:solidFill>
                   <a:srgbClr val="202020"/>
                 </a:solidFill>
@@ -3573,11 +4062,11 @@
           <a:p>
             <a:pPr>
               <a:spcAft>
-                <a:spcPts val="800"/>
+                <a:spcPts val="700"/>
               </a:spcAft>
             </a:pPr>
             <a:r>
-              <a:rPr sz="2200">
+              <a:rPr sz="2100">
                 <a:solidFill>
                   <a:srgbClr val="202020"/>
                 </a:solidFill>
@@ -3588,11 +4077,11 @@
           <a:p>
             <a:pPr>
               <a:spcAft>
-                <a:spcPts val="800"/>
+                <a:spcPts val="700"/>
               </a:spcAft>
             </a:pPr>
             <a:r>
-              <a:rPr sz="2200">
+              <a:rPr sz="2100">
                 <a:solidFill>
                   <a:srgbClr val="202020"/>
                 </a:solidFill>
@@ -3603,11 +4092,11 @@
           <a:p>
             <a:pPr>
               <a:spcAft>
-                <a:spcPts val="800"/>
+                <a:spcPts val="700"/>
               </a:spcAft>
             </a:pPr>
             <a:r>
-              <a:rPr sz="2200">
+              <a:rPr sz="2100">
                 <a:solidFill>
                   <a:srgbClr val="202020"/>
                 </a:solidFill>
@@ -3618,11 +4107,11 @@
           <a:p>
             <a:pPr>
               <a:spcAft>
-                <a:spcPts val="800"/>
+                <a:spcPts val="700"/>
               </a:spcAft>
             </a:pPr>
             <a:r>
-              <a:rPr sz="2200">
+              <a:rPr sz="2100">
                 <a:solidFill>
                   <a:srgbClr val="202020"/>
                 </a:solidFill>
@@ -3659,7 +4148,7 @@
         <p:spPr>
           <a:xfrm>
             <a:off x="0" y="0"/>
-            <a:ext cx="12191695" cy="1005840"/>
+            <a:ext cx="12191695" cy="914400"/>
           </a:xfrm>
           <a:prstGeom prst="rect">
             <a:avLst/>
@@ -3702,8 +4191,8 @@
         </p:nvSpPr>
         <p:spPr>
           <a:xfrm>
-            <a:off x="548640" y="164592"/>
-            <a:ext cx="10972800" cy="731520"/>
+            <a:off x="548640" y="109728"/>
+            <a:ext cx="11064240" cy="694944"/>
           </a:xfrm>
           <a:prstGeom prst="rect">
             <a:avLst/>
@@ -3718,7 +4207,7 @@
           <a:p>
             <a:pPr algn="l"/>
             <a:r>
-              <a:rPr sz="3000" b="1">
+              <a:rPr sz="2800" b="1">
                 <a:solidFill>
                   <a:srgbClr val="FFFFFF"/>
                 </a:solidFill>
@@ -3728,104 +4217,293 @@
           </a:p>
         </p:txBody>
       </p:sp>
-      <p:sp>
-        <p:nvSpPr>
-          <p:cNvPr id="4" name="TextBox 3"/>
-          <p:cNvSpPr txBox="1"/>
+      <p:graphicFrame>
+        <p:nvGraphicFramePr>
+          <p:cNvPr id="4" name="Table 3"/>
+          <p:cNvGraphicFramePr>
+            <a:graphicFrameLocks noGrp="1"/>
+          </p:cNvGraphicFramePr>
           <p:nvPr/>
-        </p:nvSpPr>
-        <p:spPr>
-          <a:xfrm>
-            <a:off x="731520" y="1371600"/>
-            <a:ext cx="10698480" cy="4937760"/>
-          </a:xfrm>
-          <a:prstGeom prst="rect">
-            <a:avLst/>
-          </a:prstGeom>
-          <a:noFill/>
-        </p:spPr>
-        <p:txBody>
-          <a:bodyPr wrap="square">
-            <a:spAutoFit/>
-          </a:bodyPr>
-          <a:lstStyle/>
-          <a:p>
-            <a:pPr>
-              <a:spcAft>
-                <a:spcPts val="800"/>
-              </a:spcAft>
-            </a:pPr>
-            <a:r>
-              <a:rPr sz="2200">
-                <a:solidFill>
-                  <a:srgbClr val="202020"/>
-                </a:solidFill>
-              </a:rPr>
-              <a:t>• Microsoft Fabric has two separate control planes — the portal covers neither repeatably:</a:t>
-            </a:r>
-          </a:p>
-          <a:p>
-            <a:pPr lvl="1">
-              <a:spcAft>
-                <a:spcPts val="800"/>
-              </a:spcAft>
-            </a:pPr>
-            <a:r>
-              <a:rPr sz="1800">
-                <a:solidFill>
-                  <a:srgbClr val="555555"/>
-                </a:solidFill>
-              </a:rPr>
-              <a:t>– Azure — the Fabric capacity (Microsoft.Fabric/capacities), the billable compute</a:t>
-            </a:r>
-          </a:p>
-          <a:p>
-            <a:pPr lvl="1">
-              <a:spcAft>
-                <a:spcPts val="800"/>
-              </a:spcAft>
-            </a:pPr>
-            <a:r>
-              <a:rPr sz="1800">
-                <a:solidFill>
-                  <a:srgbClr val="555555"/>
-                </a:solidFill>
-              </a:rPr>
-              <a:t>– Fabric — workspaces and items: Lakehouse, Warehouse, Notebook, Pipeline…</a:t>
-            </a:r>
-          </a:p>
-          <a:p>
-            <a:pPr lvl="1">
-              <a:spcAft>
-                <a:spcPts val="800"/>
-              </a:spcAft>
-            </a:pPr>
-            <a:r>
-              <a:rPr sz="1800">
-                <a:solidFill>
-                  <a:srgbClr val="555555"/>
-                </a:solidFill>
-              </a:rPr>
-              <a:t>– Data — objects inside an item, e.g. stored procedures in a Warehouse</a:t>
-            </a:r>
-          </a:p>
-          <a:p>
-            <a:pPr>
-              <a:spcAft>
-                <a:spcPts val="800"/>
-              </a:spcAft>
-            </a:pPr>
-            <a:r>
-              <a:rPr sz="2200">
-                <a:solidFill>
-                  <a:srgbClr val="202020"/>
-                </a:solidFill>
-              </a:rPr>
-              <a:t>• ARM/portal cannot create workspaces or items — only the Fabric REST API can.</a:t>
-            </a:r>
-          </a:p>
-        </p:txBody>
-      </p:sp>
+        </p:nvGraphicFramePr>
+        <p:xfrm>
+          <a:off x="548640" y="1234440"/>
+          <a:ext cx="10698480" cy="5120640"/>
+        </p:xfrm>
+        <a:graphic>
+          <a:graphicData uri="http://schemas.openxmlformats.org/drawingml/2006/table">
+            <a:tbl>
+              <a:tblPr firstRow="1" bandRow="1">
+                <a:tableStyleId>{5C22544A-7EE6-4342-B048-85BDC9FD1C3A}</a:tableStyleId>
+              </a:tblPr>
+              <a:tblGrid>
+                <a:gridCol w="1463040"/>
+                <a:gridCol w="7040880"/>
+                <a:gridCol w="2194560"/>
+              </a:tblGrid>
+              <a:tr h="1280160">
+                <a:tc>
+                  <a:txBody>
+                    <a:bodyPr wrap="square"/>
+                    <a:lstStyle/>
+                    <a:p>
+                      <a:r>
+                        <a:rPr b="1" sz="1500">
+                          <a:solidFill>
+                            <a:srgbClr val="FFFFFF"/>
+                          </a:solidFill>
+                        </a:rPr>
+                        <a:t>Layer</a:t>
+                      </a:r>
+                    </a:p>
+                  </a:txBody>
+                  <a:tcPr>
+                    <a:solidFill>
+                      <a:srgbClr val="117365"/>
+                    </a:solidFill>
+                  </a:tcPr>
+                </a:tc>
+                <a:tc>
+                  <a:txBody>
+                    <a:bodyPr wrap="square"/>
+                    <a:lstStyle/>
+                    <a:p>
+                      <a:r>
+                        <a:rPr b="1" sz="1500">
+                          <a:solidFill>
+                            <a:srgbClr val="FFFFFF"/>
+                          </a:solidFill>
+                        </a:rPr>
+                        <a:t>What it manages</a:t>
+                      </a:r>
+                    </a:p>
+                  </a:txBody>
+                  <a:tcPr>
+                    <a:solidFill>
+                      <a:srgbClr val="117365"/>
+                    </a:solidFill>
+                  </a:tcPr>
+                </a:tc>
+                <a:tc>
+                  <a:txBody>
+                    <a:bodyPr wrap="square"/>
+                    <a:lstStyle/>
+                    <a:p>
+                      <a:r>
+                        <a:rPr b="1" sz="1500">
+                          <a:solidFill>
+                            <a:srgbClr val="FFFFFF"/>
+                          </a:solidFill>
+                        </a:rPr>
+                        <a:t>Tooling here</a:t>
+                      </a:r>
+                    </a:p>
+                  </a:txBody>
+                  <a:tcPr>
+                    <a:solidFill>
+                      <a:srgbClr val="117365"/>
+                    </a:solidFill>
+                  </a:tcPr>
+                </a:tc>
+              </a:tr>
+              <a:tr h="1280160">
+                <a:tc>
+                  <a:txBody>
+                    <a:bodyPr wrap="square"/>
+                    <a:lstStyle/>
+                    <a:p>
+                      <a:r>
+                        <a:rPr sz="1300" b="1">
+                          <a:solidFill>
+                            <a:srgbClr val="202020"/>
+                          </a:solidFill>
+                        </a:rPr>
+                        <a:t>Azure</a:t>
+                      </a:r>
+                    </a:p>
+                  </a:txBody>
+                  <a:tcPr>
+                    <a:solidFill>
+                      <a:srgbClr val="FFFFFF"/>
+                    </a:solidFill>
+                  </a:tcPr>
+                </a:tc>
+                <a:tc>
+                  <a:txBody>
+                    <a:bodyPr wrap="square"/>
+                    <a:lstStyle/>
+                    <a:p>
+                      <a:r>
+                        <a:rPr sz="1300">
+                          <a:solidFill>
+                            <a:srgbClr val="202020"/>
+                          </a:solidFill>
+                        </a:rPr>
+                        <a:t>Fabric capacity (Microsoft.Fabric/capacities) — billable compute</a:t>
+                      </a:r>
+                    </a:p>
+                  </a:txBody>
+                  <a:tcPr>
+                    <a:solidFill>
+                      <a:srgbClr val="FFFFFF"/>
+                    </a:solidFill>
+                  </a:tcPr>
+                </a:tc>
+                <a:tc>
+                  <a:txBody>
+                    <a:bodyPr wrap="square"/>
+                    <a:lstStyle/>
+                    <a:p>
+                      <a:r>
+                        <a:rPr sz="1300">
+                          <a:solidFill>
+                            <a:srgbClr val="202020"/>
+                          </a:solidFill>
+                        </a:rPr>
+                        <a:t>Bicep + az</a:t>
+                      </a:r>
+                    </a:p>
+                  </a:txBody>
+                  <a:tcPr>
+                    <a:solidFill>
+                      <a:srgbClr val="FFFFFF"/>
+                    </a:solidFill>
+                  </a:tcPr>
+                </a:tc>
+              </a:tr>
+              <a:tr h="1280160">
+                <a:tc>
+                  <a:txBody>
+                    <a:bodyPr wrap="square"/>
+                    <a:lstStyle/>
+                    <a:p>
+                      <a:r>
+                        <a:rPr sz="1300" b="1">
+                          <a:solidFill>
+                            <a:srgbClr val="202020"/>
+                          </a:solidFill>
+                        </a:rPr>
+                        <a:t>Fabric</a:t>
+                      </a:r>
+                    </a:p>
+                  </a:txBody>
+                  <a:tcPr>
+                    <a:solidFill>
+                      <a:srgbClr val="E3F1EE"/>
+                    </a:solidFill>
+                  </a:tcPr>
+                </a:tc>
+                <a:tc>
+                  <a:txBody>
+                    <a:bodyPr wrap="square"/>
+                    <a:lstStyle/>
+                    <a:p>
+                      <a:r>
+                        <a:rPr sz="1300">
+                          <a:solidFill>
+                            <a:srgbClr val="202020"/>
+                          </a:solidFill>
+                        </a:rPr>
+                        <a:t>Workspaces + items (Lakehouse, Warehouse, Notebook, Pipeline)</a:t>
+                      </a:r>
+                    </a:p>
+                  </a:txBody>
+                  <a:tcPr>
+                    <a:solidFill>
+                      <a:srgbClr val="E3F1EE"/>
+                    </a:solidFill>
+                  </a:tcPr>
+                </a:tc>
+                <a:tc>
+                  <a:txBody>
+                    <a:bodyPr wrap="square"/>
+                    <a:lstStyle/>
+                    <a:p>
+                      <a:r>
+                        <a:rPr sz="1300">
+                          <a:solidFill>
+                            <a:srgbClr val="202020"/>
+                          </a:solidFill>
+                        </a:rPr>
+                        <a:t>Fabric REST</a:t>
+                      </a:r>
+                    </a:p>
+                  </a:txBody>
+                  <a:tcPr>
+                    <a:solidFill>
+                      <a:srgbClr val="E3F1EE"/>
+                    </a:solidFill>
+                  </a:tcPr>
+                </a:tc>
+              </a:tr>
+              <a:tr h="1280160">
+                <a:tc>
+                  <a:txBody>
+                    <a:bodyPr wrap="square"/>
+                    <a:lstStyle/>
+                    <a:p>
+                      <a:r>
+                        <a:rPr sz="1300" b="1">
+                          <a:solidFill>
+                            <a:srgbClr val="202020"/>
+                          </a:solidFill>
+                        </a:rPr>
+                        <a:t>Data</a:t>
+                      </a:r>
+                    </a:p>
+                  </a:txBody>
+                  <a:tcPr>
+                    <a:solidFill>
+                      <a:srgbClr val="FFFFFF"/>
+                    </a:solidFill>
+                  </a:tcPr>
+                </a:tc>
+                <a:tc>
+                  <a:txBody>
+                    <a:bodyPr wrap="square"/>
+                    <a:lstStyle/>
+                    <a:p>
+                      <a:r>
+                        <a:rPr sz="1300">
+                          <a:solidFill>
+                            <a:srgbClr val="202020"/>
+                          </a:solidFill>
+                        </a:rPr>
+                        <a:t>Objects inside an item — e.g. stored procedures</a:t>
+                      </a:r>
+                    </a:p>
+                  </a:txBody>
+                  <a:tcPr>
+                    <a:solidFill>
+                      <a:srgbClr val="FFFFFF"/>
+                    </a:solidFill>
+                  </a:tcPr>
+                </a:tc>
+                <a:tc>
+                  <a:txBody>
+                    <a:bodyPr wrap="square"/>
+                    <a:lstStyle/>
+                    <a:p>
+                      <a:r>
+                        <a:rPr sz="1300">
+                          <a:solidFill>
+                            <a:srgbClr val="202020"/>
+                          </a:solidFill>
+                        </a:rPr>
+                        <a:t>T-SQL</a:t>
+                      </a:r>
+                    </a:p>
+                  </a:txBody>
+                  <a:tcPr>
+                    <a:solidFill>
+                      <a:srgbClr val="FFFFFF"/>
+                    </a:solidFill>
+                  </a:tcPr>
+                </a:tc>
+              </a:tr>
+            </a:tbl>
+          </a:graphicData>
+        </a:graphic>
+      </p:graphicFrame>
     </p:spTree>
   </p:cSld>
   <p:clrMapOvr>
@@ -3853,7 +4531,7 @@
         <p:spPr>
           <a:xfrm>
             <a:off x="0" y="0"/>
-            <a:ext cx="12191695" cy="1005840"/>
+            <a:ext cx="12191695" cy="914400"/>
           </a:xfrm>
           <a:prstGeom prst="rect">
             <a:avLst/>
@@ -3896,8 +4574,8 @@
         </p:nvSpPr>
         <p:spPr>
           <a:xfrm>
-            <a:off x="548640" y="164592"/>
-            <a:ext cx="10972800" cy="731520"/>
+            <a:off x="548640" y="109728"/>
+            <a:ext cx="11064240" cy="694944"/>
           </a:xfrm>
           <a:prstGeom prst="rect">
             <a:avLst/>
@@ -3912,159 +4590,350 @@
           <a:p>
             <a:pPr algn="l"/>
             <a:r>
-              <a:rPr sz="3000" b="1">
+              <a:rPr sz="2800" b="1">
                 <a:solidFill>
                   <a:srgbClr val="FFFFFF"/>
                 </a:solidFill>
               </a:rPr>
-              <a:t>What this repo does</a:t>
-            </a:r>
-          </a:p>
-        </p:txBody>
-      </p:sp>
-      <p:sp>
-        <p:nvSpPr>
-          <p:cNvPr id="4" name="TextBox 3"/>
-          <p:cNvSpPr txBox="1"/>
+              <a:t>The building blocks — what each part does</a:t>
+            </a:r>
+          </a:p>
+        </p:txBody>
+      </p:sp>
+      <p:graphicFrame>
+        <p:nvGraphicFramePr>
+          <p:cNvPr id="4" name="Table 3"/>
+          <p:cNvGraphicFramePr>
+            <a:graphicFrameLocks noGrp="1"/>
+          </p:cNvGraphicFramePr>
           <p:nvPr/>
-        </p:nvSpPr>
-        <p:spPr>
-          <a:xfrm>
-            <a:off x="731520" y="1371600"/>
-            <a:ext cx="10698480" cy="4937760"/>
-          </a:xfrm>
-          <a:prstGeom prst="rect">
-            <a:avLst/>
-          </a:prstGeom>
-          <a:noFill/>
-        </p:spPr>
-        <p:txBody>
-          <a:bodyPr wrap="square">
-            <a:spAutoFit/>
-          </a:bodyPr>
-          <a:lstStyle/>
-          <a:p>
-            <a:pPr>
-              <a:spcAft>
-                <a:spcPts val="800"/>
-              </a:spcAft>
-            </a:pPr>
-            <a:r>
-              <a:rPr sz="2200">
-                <a:solidFill>
-                  <a:srgbClr val="202020"/>
-                </a:solidFill>
-              </a:rPr>
-              <a:t>• One config file drives a fully working environment:</a:t>
-            </a:r>
-          </a:p>
-          <a:p>
-            <a:pPr lvl="1">
-              <a:spcAft>
-                <a:spcPts val="800"/>
-              </a:spcAft>
-            </a:pPr>
-            <a:r>
-              <a:rPr sz="1800">
-                <a:solidFill>
-                  <a:srgbClr val="555555"/>
-                </a:solidFill>
-              </a:rPr>
-              <a:t>– Provision a resource group + Fabric capacity (Bicep)</a:t>
-            </a:r>
-          </a:p>
-          <a:p>
-            <a:pPr lvl="1">
-              <a:spcAft>
-                <a:spcPts val="800"/>
-              </a:spcAft>
-            </a:pPr>
-            <a:r>
-              <a:rPr sz="1800">
-                <a:solidFill>
-                  <a:srgbClr val="555555"/>
-                </a:solidFill>
-              </a:rPr>
-              <a:t>– Create a Fabric workspace (REST)</a:t>
-            </a:r>
-          </a:p>
-          <a:p>
-            <a:pPr lvl="1">
-              <a:spcAft>
-                <a:spcPts val="800"/>
-              </a:spcAft>
-            </a:pPr>
-            <a:r>
-              <a:rPr sz="1800">
-                <a:solidFill>
-                  <a:srgbClr val="555555"/>
-                </a:solidFill>
-              </a:rPr>
-              <a:t>– Assign the workspace to the capacity (REST)</a:t>
-            </a:r>
-          </a:p>
-          <a:p>
-            <a:pPr lvl="1">
-              <a:spcAft>
-                <a:spcPts val="800"/>
-              </a:spcAft>
-            </a:pPr>
-            <a:r>
-              <a:rPr sz="1800">
-                <a:solidFill>
-                  <a:srgbClr val="555555"/>
-                </a:solidFill>
-              </a:rPr>
-              <a:t>– Deploy items — Lakehouse, Warehouse, Notebook, Data Pipeline (REST)</a:t>
-            </a:r>
-          </a:p>
-          <a:p>
-            <a:pPr lvl="1">
-              <a:spcAft>
-                <a:spcPts val="800"/>
-              </a:spcAft>
-            </a:pPr>
-            <a:r>
-              <a:rPr sz="1800">
-                <a:solidFill>
-                  <a:srgbClr val="555555"/>
-                </a:solidFill>
-              </a:rPr>
-              <a:t>– Deploy stored procedures into the Warehouse (T-SQL)</a:t>
-            </a:r>
-          </a:p>
-          <a:p>
-            <a:pPr lvl="1">
-              <a:spcAft>
-                <a:spcPts val="800"/>
-              </a:spcAft>
-            </a:pPr>
-            <a:r>
-              <a:rPr sz="1800">
-                <a:solidFill>
-                  <a:srgbClr val="555555"/>
-                </a:solidFill>
-              </a:rPr>
-              <a:t>– Optional: connect the workspace to Git</a:t>
-            </a:r>
-          </a:p>
-          <a:p>
-            <a:pPr>
-              <a:spcAft>
-                <a:spcPts val="800"/>
-              </a:spcAft>
-            </a:pPr>
-            <a:r>
-              <a:rPr sz="2200">
-                <a:solidFill>
-                  <a:srgbClr val="202020"/>
-                </a:solidFill>
-              </a:rPr>
-              <a:t>• Every step is idempotent and parameter-driven — re-runnable and safe.</a:t>
-            </a:r>
-          </a:p>
-        </p:txBody>
-      </p:sp>
+        </p:nvGraphicFramePr>
+        <p:xfrm>
+          <a:off x="548640" y="1234440"/>
+          <a:ext cx="10698480" cy="5120640"/>
+        </p:xfrm>
+        <a:graphic>
+          <a:graphicData uri="http://schemas.openxmlformats.org/drawingml/2006/table">
+            <a:tbl>
+              <a:tblPr firstRow="1" bandRow="1">
+                <a:tableStyleId>{5C22544A-7EE6-4342-B048-85BDC9FD1C3A}</a:tableStyleId>
+              </a:tblPr>
+              <a:tblGrid>
+                <a:gridCol w="2377440"/>
+                <a:gridCol w="8321040"/>
+              </a:tblGrid>
+              <a:tr h="731520">
+                <a:tc>
+                  <a:txBody>
+                    <a:bodyPr wrap="square"/>
+                    <a:lstStyle/>
+                    <a:p>
+                      <a:r>
+                        <a:rPr b="1" sz="1500">
+                          <a:solidFill>
+                            <a:srgbClr val="FFFFFF"/>
+                          </a:solidFill>
+                        </a:rPr>
+                        <a:t>Component</a:t>
+                      </a:r>
+                    </a:p>
+                  </a:txBody>
+                  <a:tcPr>
+                    <a:solidFill>
+                      <a:srgbClr val="117365"/>
+                    </a:solidFill>
+                  </a:tcPr>
+                </a:tc>
+                <a:tc>
+                  <a:txBody>
+                    <a:bodyPr wrap="square"/>
+                    <a:lstStyle/>
+                    <a:p>
+                      <a:r>
+                        <a:rPr b="1" sz="1500">
+                          <a:solidFill>
+                            <a:srgbClr val="FFFFFF"/>
+                          </a:solidFill>
+                        </a:rPr>
+                        <a:t>What it is / does</a:t>
+                      </a:r>
+                    </a:p>
+                  </a:txBody>
+                  <a:tcPr>
+                    <a:solidFill>
+                      <a:srgbClr val="117365"/>
+                    </a:solidFill>
+                  </a:tcPr>
+                </a:tc>
+              </a:tr>
+              <a:tr h="731520">
+                <a:tc>
+                  <a:txBody>
+                    <a:bodyPr wrap="square"/>
+                    <a:lstStyle/>
+                    <a:p>
+                      <a:r>
+                        <a:rPr sz="1300" b="1">
+                          <a:solidFill>
+                            <a:srgbClr val="202020"/>
+                          </a:solidFill>
+                        </a:rPr>
+                        <a:t>Capacity (F-SKU)</a:t>
+                      </a:r>
+                    </a:p>
+                  </a:txBody>
+                  <a:tcPr>
+                    <a:solidFill>
+                      <a:srgbClr val="FFFFFF"/>
+                    </a:solidFill>
+                  </a:tcPr>
+                </a:tc>
+                <a:tc>
+                  <a:txBody>
+                    <a:bodyPr wrap="square"/>
+                    <a:lstStyle/>
+                    <a:p>
+                      <a:r>
+                        <a:rPr sz="1300">
+                          <a:solidFill>
+                            <a:srgbClr val="202020"/>
+                          </a:solidFill>
+                        </a:rPr>
+                        <a:t>The compute every item runs on. Billed hourly; pause to stop.</a:t>
+                      </a:r>
+                    </a:p>
+                  </a:txBody>
+                  <a:tcPr>
+                    <a:solidFill>
+                      <a:srgbClr val="FFFFFF"/>
+                    </a:solidFill>
+                  </a:tcPr>
+                </a:tc>
+              </a:tr>
+              <a:tr h="731520">
+                <a:tc>
+                  <a:txBody>
+                    <a:bodyPr wrap="square"/>
+                    <a:lstStyle/>
+                    <a:p>
+                      <a:r>
+                        <a:rPr sz="1300" b="1">
+                          <a:solidFill>
+                            <a:srgbClr val="202020"/>
+                          </a:solidFill>
+                        </a:rPr>
+                        <a:t>Workspace</a:t>
+                      </a:r>
+                    </a:p>
+                  </a:txBody>
+                  <a:tcPr>
+                    <a:solidFill>
+                      <a:srgbClr val="E3F1EE"/>
+                    </a:solidFill>
+                  </a:tcPr>
+                </a:tc>
+                <a:tc>
+                  <a:txBody>
+                    <a:bodyPr wrap="square"/>
+                    <a:lstStyle/>
+                    <a:p>
+                      <a:r>
+                        <a:rPr sz="1300">
+                          <a:solidFill>
+                            <a:srgbClr val="202020"/>
+                          </a:solidFill>
+                        </a:rPr>
+                        <a:t>Logical container for items; must sit on a capacity.</a:t>
+                      </a:r>
+                    </a:p>
+                  </a:txBody>
+                  <a:tcPr>
+                    <a:solidFill>
+                      <a:srgbClr val="E3F1EE"/>
+                    </a:solidFill>
+                  </a:tcPr>
+                </a:tc>
+              </a:tr>
+              <a:tr h="731520">
+                <a:tc>
+                  <a:txBody>
+                    <a:bodyPr wrap="square"/>
+                    <a:lstStyle/>
+                    <a:p>
+                      <a:r>
+                        <a:rPr sz="1300" b="1">
+                          <a:solidFill>
+                            <a:srgbClr val="202020"/>
+                          </a:solidFill>
+                        </a:rPr>
+                        <a:t>Lakehouse</a:t>
+                      </a:r>
+                    </a:p>
+                  </a:txBody>
+                  <a:tcPr>
+                    <a:solidFill>
+                      <a:srgbClr val="FFFFFF"/>
+                    </a:solidFill>
+                  </a:tcPr>
+                </a:tc>
+                <a:tc>
+                  <a:txBody>
+                    <a:bodyPr wrap="square"/>
+                    <a:lstStyle/>
+                    <a:p>
+                      <a:r>
+                        <a:rPr sz="1300">
+                          <a:solidFill>
+                            <a:srgbClr val="202020"/>
+                          </a:solidFill>
+                        </a:rPr>
+                        <a:t>OneLake files + Delta tables; auto SQL endpoint (read-only T-SQL).</a:t>
+                      </a:r>
+                    </a:p>
+                  </a:txBody>
+                  <a:tcPr>
+                    <a:solidFill>
+                      <a:srgbClr val="FFFFFF"/>
+                    </a:solidFill>
+                  </a:tcPr>
+                </a:tc>
+              </a:tr>
+              <a:tr h="731520">
+                <a:tc>
+                  <a:txBody>
+                    <a:bodyPr wrap="square"/>
+                    <a:lstStyle/>
+                    <a:p>
+                      <a:r>
+                        <a:rPr sz="1300" b="1">
+                          <a:solidFill>
+                            <a:srgbClr val="202020"/>
+                          </a:solidFill>
+                        </a:rPr>
+                        <a:t>Warehouse</a:t>
+                      </a:r>
+                    </a:p>
+                  </a:txBody>
+                  <a:tcPr>
+                    <a:solidFill>
+                      <a:srgbClr val="E3F1EE"/>
+                    </a:solidFill>
+                  </a:tcPr>
+                </a:tc>
+                <a:tc>
+                  <a:txBody>
+                    <a:bodyPr wrap="square"/>
+                    <a:lstStyle/>
+                    <a:p>
+                      <a:r>
+                        <a:rPr sz="1300">
+                          <a:solidFill>
+                            <a:srgbClr val="202020"/>
+                          </a:solidFill>
+                        </a:rPr>
+                        <a:t>Full read/write T-SQL engine: tables, views, stored procs, transactions.</a:t>
+                      </a:r>
+                    </a:p>
+                  </a:txBody>
+                  <a:tcPr>
+                    <a:solidFill>
+                      <a:srgbClr val="E3F1EE"/>
+                    </a:solidFill>
+                  </a:tcPr>
+                </a:tc>
+              </a:tr>
+              <a:tr h="731520">
+                <a:tc>
+                  <a:txBody>
+                    <a:bodyPr wrap="square"/>
+                    <a:lstStyle/>
+                    <a:p>
+                      <a:r>
+                        <a:rPr sz="1300" b="1">
+                          <a:solidFill>
+                            <a:srgbClr val="202020"/>
+                          </a:solidFill>
+                        </a:rPr>
+                        <a:t>Notebook</a:t>
+                      </a:r>
+                    </a:p>
+                  </a:txBody>
+                  <a:tcPr>
+                    <a:solidFill>
+                      <a:srgbClr val="FFFFFF"/>
+                    </a:solidFill>
+                  </a:tcPr>
+                </a:tc>
+                <a:tc>
+                  <a:txBody>
+                    <a:bodyPr wrap="square"/>
+                    <a:lstStyle/>
+                    <a:p>
+                      <a:r>
+                        <a:rPr sz="1300">
+                          <a:solidFill>
+                            <a:srgbClr val="202020"/>
+                          </a:solidFill>
+                        </a:rPr>
+                        <a:t>Spark/PySpark compute; bound to a Lakehouse to read/write tables.</a:t>
+                      </a:r>
+                    </a:p>
+                  </a:txBody>
+                  <a:tcPr>
+                    <a:solidFill>
+                      <a:srgbClr val="FFFFFF"/>
+                    </a:solidFill>
+                  </a:tcPr>
+                </a:tc>
+              </a:tr>
+              <a:tr h="731520">
+                <a:tc>
+                  <a:txBody>
+                    <a:bodyPr wrap="square"/>
+                    <a:lstStyle/>
+                    <a:p>
+                      <a:r>
+                        <a:rPr sz="1300" b="1">
+                          <a:solidFill>
+                            <a:srgbClr val="202020"/>
+                          </a:solidFill>
+                        </a:rPr>
+                        <a:t>Data Pipeline</a:t>
+                      </a:r>
+                    </a:p>
+                  </a:txBody>
+                  <a:tcPr>
+                    <a:solidFill>
+                      <a:srgbClr val="E3F1EE"/>
+                    </a:solidFill>
+                  </a:tcPr>
+                </a:tc>
+                <a:tc>
+                  <a:txBody>
+                    <a:bodyPr wrap="square"/>
+                    <a:lstStyle/>
+                    <a:p>
+                      <a:r>
+                        <a:rPr sz="1300">
+                          <a:solidFill>
+                            <a:srgbClr val="202020"/>
+                          </a:solidFill>
+                        </a:rPr>
+                        <a:t>Orchestrator chaining notebooks, copies and stored procedures.</a:t>
+                      </a:r>
+                    </a:p>
+                  </a:txBody>
+                  <a:tcPr>
+                    <a:solidFill>
+                      <a:srgbClr val="E3F1EE"/>
+                    </a:solidFill>
+                  </a:tcPr>
+                </a:tc>
+              </a:tr>
+            </a:tbl>
+          </a:graphicData>
+        </a:graphic>
+      </p:graphicFrame>
     </p:spTree>
   </p:cSld>
   <p:clrMapOvr>
@@ -4092,7 +4961,7 @@
         <p:spPr>
           <a:xfrm>
             <a:off x="0" y="0"/>
-            <a:ext cx="12191695" cy="1005840"/>
+            <a:ext cx="12191695" cy="914400"/>
           </a:xfrm>
           <a:prstGeom prst="rect">
             <a:avLst/>
@@ -4135,8 +5004,8 @@
         </p:nvSpPr>
         <p:spPr>
           <a:xfrm>
-            <a:off x="548640" y="164592"/>
-            <a:ext cx="10972800" cy="731520"/>
+            <a:off x="548640" y="109728"/>
+            <a:ext cx="11064240" cy="694944"/>
           </a:xfrm>
           <a:prstGeom prst="rect">
             <a:avLst/>
@@ -4151,12 +5020,12 @@
           <a:p>
             <a:pPr algn="l"/>
             <a:r>
-              <a:rPr sz="3000" b="1">
+              <a:rPr sz="2800" b="1">
                 <a:solidFill>
                   <a:srgbClr val="FFFFFF"/>
                 </a:solidFill>
               </a:rPr>
-              <a:t>Repeatable by design</a:t>
+              <a:t>What the automation does (6 steps)</a:t>
             </a:r>
           </a:p>
         </p:txBody>
@@ -4169,8 +5038,8 @@
         </p:nvSpPr>
         <p:spPr>
           <a:xfrm>
-            <a:off x="731520" y="1371600"/>
-            <a:ext cx="10698480" cy="4937760"/>
+            <a:off x="731520" y="1280160"/>
+            <a:ext cx="10698480" cy="5120640"/>
           </a:xfrm>
           <a:prstGeom prst="rect">
             <a:avLst/>
@@ -4185,91 +5054,106 @@
           <a:p>
             <a:pPr>
               <a:spcAft>
-                <a:spcPts val="800"/>
+                <a:spcPts val="700"/>
               </a:spcAft>
             </a:pPr>
             <a:r>
-              <a:rPr sz="2200">
+              <a:rPr sz="2100">
                 <a:solidFill>
                   <a:srgbClr val="202020"/>
                 </a:solidFill>
               </a:rPr>
-              <a:t>• All tenant / subscription / secret values live in a git-ignored .env</a:t>
+              <a:t>• Provision resource group + Fabric capacity — 02 → infra/capacity.bicep</a:t>
             </a:r>
           </a:p>
           <a:p>
             <a:pPr>
               <a:spcAft>
-                <a:spcPts val="800"/>
+                <a:spcPts val="700"/>
               </a:spcAft>
             </a:pPr>
             <a:r>
-              <a:rPr sz="2200">
+              <a:rPr sz="2100">
                 <a:solidFill>
                   <a:srgbClr val="202020"/>
                 </a:solidFill>
               </a:rPr>
-              <a:t>• Duplicate .env per environment: .env.dev, .env.customerA, …</a:t>
+              <a:t>• Create the workspace — 03 → POST /v1/workspaces</a:t>
             </a:r>
           </a:p>
           <a:p>
             <a:pPr>
               <a:spcAft>
-                <a:spcPts val="800"/>
+                <a:spcPts val="700"/>
               </a:spcAft>
             </a:pPr>
             <a:r>
-              <a:rPr sz="2200">
+              <a:rPr sz="2100">
                 <a:solidFill>
                   <a:srgbClr val="202020"/>
                 </a:solidFill>
               </a:rPr>
-              <a:t>• Same scripts, different config → identical environment in any tenant / RG</a:t>
+              <a:t>• Assign workspace to capacity — 04 → assignToCapacity (unlocks items)</a:t>
             </a:r>
           </a:p>
           <a:p>
             <a:pPr>
               <a:spcAft>
-                <a:spcPts val="800"/>
+                <a:spcPts val="700"/>
               </a:spcAft>
             </a:pPr>
             <a:r>
-              <a:rPr sz="2200">
+              <a:rPr sz="2100">
                 <a:solidFill>
                   <a:srgbClr val="202020"/>
                 </a:solidFill>
               </a:rPr>
-              <a:t>• Service-principal auth for CI/CD and multi-tenant automation</a:t>
+              <a:t>• Deploy items — 05 → Lakehouse, Warehouse, Notebook, Pipeline</a:t>
             </a:r>
           </a:p>
           <a:p>
             <a:pPr>
               <a:spcAft>
-                <a:spcPts val="800"/>
+                <a:spcPts val="700"/>
               </a:spcAft>
             </a:pPr>
             <a:r>
-              <a:rPr sz="2200">
+              <a:rPr sz="2100">
                 <a:solidFill>
                   <a:srgbClr val="202020"/>
                 </a:solidFill>
               </a:rPr>
-              <a:t>• PowerShell and bash versions of every script</a:t>
+              <a:t>• Deploy stored procedures — 06 → T-SQL to the Warehouse SQL endpoint</a:t>
             </a:r>
           </a:p>
           <a:p>
             <a:pPr>
               <a:spcAft>
-                <a:spcPts val="800"/>
+                <a:spcPts val="700"/>
               </a:spcAft>
             </a:pPr>
             <a:r>
-              <a:rPr sz="2200">
+              <a:rPr sz="2100">
                 <a:solidFill>
                   <a:srgbClr val="202020"/>
                 </a:solidFill>
               </a:rPr>
-              <a:t>• Public repo: contains no secrets</a:t>
+              <a:t>• Optional: connect to Git — 07 → workspace under source control</a:t>
+            </a:r>
+          </a:p>
+          <a:p>
+            <a:pPr>
+              <a:spcAft>
+                <a:spcPts val="700"/>
+              </a:spcAft>
+            </a:pPr>
+            <a:r>
+              <a:rPr sz="2100">
+                <a:solidFill>
+                  <a:srgbClr val="202020"/>
+                </a:solidFill>
+              </a:rPr>
+              <a:t>• Run individually to learn, or all at once with deploy-all.</a:t>
             </a:r>
           </a:p>
         </p:txBody>
@@ -4301,7 +5185,7 @@
         <p:spPr>
           <a:xfrm>
             <a:off x="0" y="0"/>
-            <a:ext cx="12191695" cy="1005840"/>
+            <a:ext cx="12191695" cy="914400"/>
           </a:xfrm>
           <a:prstGeom prst="rect">
             <a:avLst/>
@@ -4344,8 +5228,8 @@
         </p:nvSpPr>
         <p:spPr>
           <a:xfrm>
-            <a:off x="548640" y="164592"/>
-            <a:ext cx="10972800" cy="731520"/>
+            <a:off x="548640" y="109728"/>
+            <a:ext cx="11064240" cy="694944"/>
           </a:xfrm>
           <a:prstGeom prst="rect">
             <a:avLst/>
@@ -4360,74 +5244,394 @@
           <a:p>
             <a:pPr algn="l"/>
             <a:r>
-              <a:rPr sz="3000" b="1">
+              <a:rPr sz="2800" b="1">
                 <a:solidFill>
                   <a:srgbClr val="FFFFFF"/>
                 </a:solidFill>
               </a:rPr>
-              <a:t>Fabric — workspace contents</a:t>
-            </a:r>
-          </a:p>
-        </p:txBody>
-      </p:sp>
-      <p:sp>
-        <p:nvSpPr>
-          <p:cNvPr id="4" name="TextBox 3"/>
-          <p:cNvSpPr txBox="1"/>
+              <a:t>The deployment scripts (PowerShell + bash)</a:t>
+            </a:r>
+          </a:p>
+        </p:txBody>
+      </p:sp>
+      <p:graphicFrame>
+        <p:nvGraphicFramePr>
+          <p:cNvPr id="4" name="Table 3"/>
+          <p:cNvGraphicFramePr>
+            <a:graphicFrameLocks noGrp="1"/>
+          </p:cNvGraphicFramePr>
           <p:nvPr/>
-        </p:nvSpPr>
-        <p:spPr>
-          <a:xfrm>
-            <a:off x="548640" y="1097280"/>
-            <a:ext cx="11064240" cy="548640"/>
-          </a:xfrm>
-          <a:prstGeom prst="rect">
-            <a:avLst/>
-          </a:prstGeom>
-          <a:noFill/>
-        </p:spPr>
-        <p:txBody>
-          <a:bodyPr wrap="square" anchor="t">
-            <a:spAutoFit/>
-          </a:bodyPr>
-          <a:lstStyle/>
-          <a:p>
-            <a:pPr algn="l"/>
-            <a:r>
-              <a:rPr sz="1600" b="0">
-                <a:solidFill>
-                  <a:srgbClr val="555555"/>
-                </a:solidFill>
-              </a:rPr>
-              <a:t>Every item created via the Fabric REST API.</a:t>
-            </a:r>
-          </a:p>
-        </p:txBody>
-      </p:sp>
-      <p:pic>
-        <p:nvPicPr>
-          <p:cNvPr id="5" name="Picture 4" descr="01-workspace-list.png"/>
-          <p:cNvPicPr>
-            <a:picLocks noChangeAspect="1"/>
-          </p:cNvPicPr>
-          <p:nvPr/>
-        </p:nvPicPr>
-        <p:blipFill>
-          <a:blip r:embed="rId2"/>
-          <a:stretch>
-            <a:fillRect/>
-          </a:stretch>
-        </p:blipFill>
-        <p:spPr>
-          <a:xfrm>
-            <a:off x="548640" y="2196654"/>
-            <a:ext cx="11094415" cy="3744851"/>
-          </a:xfrm>
-          <a:prstGeom prst="rect">
-            <a:avLst/>
-          </a:prstGeom>
-        </p:spPr>
-      </p:pic>
+        </p:nvGraphicFramePr>
+        <p:xfrm>
+          <a:off x="548640" y="1234440"/>
+          <a:ext cx="10698480" cy="5120640"/>
+        </p:xfrm>
+        <a:graphic>
+          <a:graphicData uri="http://schemas.openxmlformats.org/drawingml/2006/table">
+            <a:tbl>
+              <a:tblPr firstRow="1" bandRow="1">
+                <a:tableStyleId>{5C22544A-7EE6-4342-B048-85BDC9FD1C3A}</a:tableStyleId>
+              </a:tblPr>
+              <a:tblGrid>
+                <a:gridCol w="2926080"/>
+                <a:gridCol w="7772400"/>
+              </a:tblGrid>
+              <a:tr h="640080">
+                <a:tc>
+                  <a:txBody>
+                    <a:bodyPr wrap="square"/>
+                    <a:lstStyle/>
+                    <a:p>
+                      <a:r>
+                        <a:rPr b="1" sz="1500">
+                          <a:solidFill>
+                            <a:srgbClr val="FFFFFF"/>
+                          </a:solidFill>
+                        </a:rPr>
+                        <a:t>Script</a:t>
+                      </a:r>
+                    </a:p>
+                  </a:txBody>
+                  <a:tcPr>
+                    <a:solidFill>
+                      <a:srgbClr val="117365"/>
+                    </a:solidFill>
+                  </a:tcPr>
+                </a:tc>
+                <a:tc>
+                  <a:txBody>
+                    <a:bodyPr wrap="square"/>
+                    <a:lstStyle/>
+                    <a:p>
+                      <a:r>
+                        <a:rPr b="1" sz="1500">
+                          <a:solidFill>
+                            <a:srgbClr val="FFFFFF"/>
+                          </a:solidFill>
+                        </a:rPr>
+                        <a:t>What it does</a:t>
+                      </a:r>
+                    </a:p>
+                  </a:txBody>
+                  <a:tcPr>
+                    <a:solidFill>
+                      <a:srgbClr val="117365"/>
+                    </a:solidFill>
+                  </a:tcPr>
+                </a:tc>
+              </a:tr>
+              <a:tr h="640080">
+                <a:tc>
+                  <a:txBody>
+                    <a:bodyPr wrap="square"/>
+                    <a:lstStyle/>
+                    <a:p>
+                      <a:r>
+                        <a:rPr sz="1300" b="1">
+                          <a:solidFill>
+                            <a:srgbClr val="202020"/>
+                          </a:solidFill>
+                        </a:rPr>
+                        <a:t>00-prerequisites</a:t>
+                      </a:r>
+                    </a:p>
+                  </a:txBody>
+                  <a:tcPr>
+                    <a:solidFill>
+                      <a:srgbClr val="FFFFFF"/>
+                    </a:solidFill>
+                  </a:tcPr>
+                </a:tc>
+                <a:tc>
+                  <a:txBody>
+                    <a:bodyPr wrap="square"/>
+                    <a:lstStyle/>
+                    <a:p>
+                      <a:r>
+                        <a:rPr sz="1300">
+                          <a:solidFill>
+                            <a:srgbClr val="202020"/>
+                          </a:solidFill>
+                        </a:rPr>
+                        <a:t>Checks az, pwsh/bash, sqlcmd, and login state</a:t>
+                      </a:r>
+                    </a:p>
+                  </a:txBody>
+                  <a:tcPr>
+                    <a:solidFill>
+                      <a:srgbClr val="FFFFFF"/>
+                    </a:solidFill>
+                  </a:tcPr>
+                </a:tc>
+              </a:tr>
+              <a:tr h="640080">
+                <a:tc>
+                  <a:txBody>
+                    <a:bodyPr wrap="square"/>
+                    <a:lstStyle/>
+                    <a:p>
+                      <a:r>
+                        <a:rPr sz="1300" b="1">
+                          <a:solidFill>
+                            <a:srgbClr val="202020"/>
+                          </a:solidFill>
+                        </a:rPr>
+                        <a:t>01-login</a:t>
+                      </a:r>
+                    </a:p>
+                  </a:txBody>
+                  <a:tcPr>
+                    <a:solidFill>
+                      <a:srgbClr val="E3F1EE"/>
+                    </a:solidFill>
+                  </a:tcPr>
+                </a:tc>
+                <a:tc>
+                  <a:txBody>
+                    <a:bodyPr wrap="square"/>
+                    <a:lstStyle/>
+                    <a:p>
+                      <a:r>
+                        <a:rPr sz="1300">
+                          <a:solidFill>
+                            <a:srgbClr val="202020"/>
+                          </a:solidFill>
+                        </a:rPr>
+                        <a:t>az login — interactive or service principal</a:t>
+                      </a:r>
+                    </a:p>
+                  </a:txBody>
+                  <a:tcPr>
+                    <a:solidFill>
+                      <a:srgbClr val="E3F1EE"/>
+                    </a:solidFill>
+                  </a:tcPr>
+                </a:tc>
+              </a:tr>
+              <a:tr h="640080">
+                <a:tc>
+                  <a:txBody>
+                    <a:bodyPr wrap="square"/>
+                    <a:lstStyle/>
+                    <a:p>
+                      <a:r>
+                        <a:rPr sz="1300" b="1">
+                          <a:solidFill>
+                            <a:srgbClr val="202020"/>
+                          </a:solidFill>
+                        </a:rPr>
+                        <a:t>02-provision-capacity</a:t>
+                      </a:r>
+                    </a:p>
+                  </a:txBody>
+                  <a:tcPr>
+                    <a:solidFill>
+                      <a:srgbClr val="FFFFFF"/>
+                    </a:solidFill>
+                  </a:tcPr>
+                </a:tc>
+                <a:tc>
+                  <a:txBody>
+                    <a:bodyPr wrap="square"/>
+                    <a:lstStyle/>
+                    <a:p>
+                      <a:r>
+                        <a:rPr sz="1300">
+                          <a:solidFill>
+                            <a:srgbClr val="202020"/>
+                          </a:solidFill>
+                        </a:rPr>
+                        <a:t>Bicep deploy of the Fabric capacity</a:t>
+                      </a:r>
+                    </a:p>
+                  </a:txBody>
+                  <a:tcPr>
+                    <a:solidFill>
+                      <a:srgbClr val="FFFFFF"/>
+                    </a:solidFill>
+                  </a:tcPr>
+                </a:tc>
+              </a:tr>
+              <a:tr h="640080">
+                <a:tc>
+                  <a:txBody>
+                    <a:bodyPr wrap="square"/>
+                    <a:lstStyle/>
+                    <a:p>
+                      <a:r>
+                        <a:rPr sz="1300" b="1">
+                          <a:solidFill>
+                            <a:srgbClr val="202020"/>
+                          </a:solidFill>
+                        </a:rPr>
+                        <a:t>03 / 04</a:t>
+                      </a:r>
+                    </a:p>
+                  </a:txBody>
+                  <a:tcPr>
+                    <a:solidFill>
+                      <a:srgbClr val="E3F1EE"/>
+                    </a:solidFill>
+                  </a:tcPr>
+                </a:tc>
+                <a:tc>
+                  <a:txBody>
+                    <a:bodyPr wrap="square"/>
+                    <a:lstStyle/>
+                    <a:p>
+                      <a:r>
+                        <a:rPr sz="1300">
+                          <a:solidFill>
+                            <a:srgbClr val="202020"/>
+                          </a:solidFill>
+                        </a:rPr>
+                        <a:t>Create workspace · assign it to the capacity</a:t>
+                      </a:r>
+                    </a:p>
+                  </a:txBody>
+                  <a:tcPr>
+                    <a:solidFill>
+                      <a:srgbClr val="E3F1EE"/>
+                    </a:solidFill>
+                  </a:tcPr>
+                </a:tc>
+              </a:tr>
+              <a:tr h="640080">
+                <a:tc>
+                  <a:txBody>
+                    <a:bodyPr wrap="square"/>
+                    <a:lstStyle/>
+                    <a:p>
+                      <a:r>
+                        <a:rPr sz="1300" b="1">
+                          <a:solidFill>
+                            <a:srgbClr val="202020"/>
+                          </a:solidFill>
+                        </a:rPr>
+                        <a:t>05-deploy-items</a:t>
+                      </a:r>
+                    </a:p>
+                  </a:txBody>
+                  <a:tcPr>
+                    <a:solidFill>
+                      <a:srgbClr val="FFFFFF"/>
+                    </a:solidFill>
+                  </a:tcPr>
+                </a:tc>
+                <a:tc>
+                  <a:txBody>
+                    <a:bodyPr wrap="square"/>
+                    <a:lstStyle/>
+                    <a:p>
+                      <a:r>
+                        <a:rPr sz="1300">
+                          <a:solidFill>
+                            <a:srgbClr val="202020"/>
+                          </a:solidFill>
+                        </a:rPr>
+                        <a:t>Create the four items from definition files</a:t>
+                      </a:r>
+                    </a:p>
+                  </a:txBody>
+                  <a:tcPr>
+                    <a:solidFill>
+                      <a:srgbClr val="FFFFFF"/>
+                    </a:solidFill>
+                  </a:tcPr>
+                </a:tc>
+              </a:tr>
+              <a:tr h="640080">
+                <a:tc>
+                  <a:txBody>
+                    <a:bodyPr wrap="square"/>
+                    <a:lstStyle/>
+                    <a:p>
+                      <a:r>
+                        <a:rPr sz="1300" b="1">
+                          <a:solidFill>
+                            <a:srgbClr val="202020"/>
+                          </a:solidFill>
+                        </a:rPr>
+                        <a:t>06-deploy-stored-procedures</a:t>
+                      </a:r>
+                    </a:p>
+                  </a:txBody>
+                  <a:tcPr>
+                    <a:solidFill>
+                      <a:srgbClr val="E3F1EE"/>
+                    </a:solidFill>
+                  </a:tcPr>
+                </a:tc>
+                <a:tc>
+                  <a:txBody>
+                    <a:bodyPr wrap="square"/>
+                    <a:lstStyle/>
+                    <a:p>
+                      <a:r>
+                        <a:rPr sz="1300">
+                          <a:solidFill>
+                            <a:srgbClr val="202020"/>
+                          </a:solidFill>
+                        </a:rPr>
+                        <a:t>Run T-SQL against the Warehouse (Entra token)</a:t>
+                      </a:r>
+                    </a:p>
+                  </a:txBody>
+                  <a:tcPr>
+                    <a:solidFill>
+                      <a:srgbClr val="E3F1EE"/>
+                    </a:solidFill>
+                  </a:tcPr>
+                </a:tc>
+              </a:tr>
+              <a:tr h="640080">
+                <a:tc>
+                  <a:txBody>
+                    <a:bodyPr wrap="square"/>
+                    <a:lstStyle/>
+                    <a:p>
+                      <a:r>
+                        <a:rPr sz="1300" b="1">
+                          <a:solidFill>
+                            <a:srgbClr val="202020"/>
+                          </a:solidFill>
+                        </a:rPr>
+                        <a:t>99-teardown</a:t>
+                      </a:r>
+                    </a:p>
+                  </a:txBody>
+                  <a:tcPr>
+                    <a:solidFill>
+                      <a:srgbClr val="FFFFFF"/>
+                    </a:solidFill>
+                  </a:tcPr>
+                </a:tc>
+                <a:tc>
+                  <a:txBody>
+                    <a:bodyPr wrap="square"/>
+                    <a:lstStyle/>
+                    <a:p>
+                      <a:r>
+                        <a:rPr sz="1300">
+                          <a:solidFill>
+                            <a:srgbClr val="202020"/>
+                          </a:solidFill>
+                        </a:rPr>
+                        <a:t>Delete the workspace and the resource group</a:t>
+                      </a:r>
+                    </a:p>
+                  </a:txBody>
+                  <a:tcPr>
+                    <a:solidFill>
+                      <a:srgbClr val="FFFFFF"/>
+                    </a:solidFill>
+                  </a:tcPr>
+                </a:tc>
+              </a:tr>
+            </a:tbl>
+          </a:graphicData>
+        </a:graphic>
+      </p:graphicFrame>
     </p:spTree>
   </p:cSld>
   <p:clrMapOvr>
@@ -4455,7 +5659,7 @@
         <p:spPr>
           <a:xfrm>
             <a:off x="0" y="0"/>
-            <a:ext cx="12191695" cy="1005840"/>
+            <a:ext cx="12191695" cy="914400"/>
           </a:xfrm>
           <a:prstGeom prst="rect">
             <a:avLst/>
@@ -4498,8 +5702,8 @@
         </p:nvSpPr>
         <p:spPr>
           <a:xfrm>
-            <a:off x="548640" y="164592"/>
-            <a:ext cx="10972800" cy="731520"/>
+            <a:off x="548640" y="109728"/>
+            <a:ext cx="11064240" cy="694944"/>
           </a:xfrm>
           <a:prstGeom prst="rect">
             <a:avLst/>
@@ -4514,12 +5718,12 @@
           <a:p>
             <a:pPr algn="l"/>
             <a:r>
-              <a:rPr sz="3000" b="1">
+              <a:rPr sz="2800" b="1">
                 <a:solidFill>
                   <a:srgbClr val="FFFFFF"/>
                 </a:solidFill>
               </a:rPr>
-              <a:t>Fabric — Lakehouse with data</a:t>
+              <a:t>How it stays reliable</a:t>
             </a:r>
           </a:p>
         </p:txBody>
@@ -4532,8 +5736,8 @@
         </p:nvSpPr>
         <p:spPr>
           <a:xfrm>
-            <a:off x="548640" y="1097280"/>
-            <a:ext cx="11064240" cy="548640"/>
+            <a:off x="731520" y="1280160"/>
+            <a:ext cx="10698480" cy="5120640"/>
           </a:xfrm>
           <a:prstGeom prst="rect">
             <a:avLst/>
@@ -4541,47 +5745,102 @@
           <a:noFill/>
         </p:spPr>
         <p:txBody>
-          <a:bodyPr wrap="square" anchor="t">
+          <a:bodyPr wrap="square">
             <a:spAutoFit/>
           </a:bodyPr>
           <a:lstStyle/>
           <a:p>
-            <a:pPr algn="l"/>
-            <a:r>
-              <a:rPr sz="1600" b="0">
-                <a:solidFill>
-                  <a:srgbClr val="555555"/>
+            <a:pPr>
+              <a:spcAft>
+                <a:spcPts val="700"/>
+              </a:spcAft>
+            </a:pPr>
+            <a:r>
+              <a:rPr sz="2100">
+                <a:solidFill>
+                  <a:srgbClr val="202020"/>
                 </a:solidFill>
               </a:rPr>
-              <a:t>orders_bronze Delta table, written by the notebook run (5 rows).</a:t>
-            </a:r>
-          </a:p>
-        </p:txBody>
-      </p:sp>
-      <p:pic>
-        <p:nvPicPr>
-          <p:cNvPr id="5" name="Picture 4" descr="02-lakehouse-table.png"/>
-          <p:cNvPicPr>
-            <a:picLocks noChangeAspect="1"/>
-          </p:cNvPicPr>
-          <p:nvPr/>
-        </p:nvPicPr>
-        <p:blipFill>
-          <a:blip r:embed="rId2"/>
-          <a:stretch>
-            <a:fillRect/>
-          </a:stretch>
-        </p:blipFill>
-        <p:spPr>
-          <a:xfrm>
-            <a:off x="548640" y="2807079"/>
-            <a:ext cx="11094415" cy="2524002"/>
-          </a:xfrm>
-          <a:prstGeom prst="rect">
-            <a:avLst/>
-          </a:prstGeom>
-        </p:spPr>
-      </p:pic>
+              <a:t>• Idempotent — existing workspaces/items are detected and reused, not duplicated</a:t>
+            </a:r>
+          </a:p>
+          <a:p>
+            <a:pPr>
+              <a:spcAft>
+                <a:spcPts val="700"/>
+              </a:spcAft>
+            </a:pPr>
+            <a:r>
+              <a:rPr sz="2100">
+                <a:solidFill>
+                  <a:srgbClr val="202020"/>
+                </a:solidFill>
+              </a:rPr>
+              <a:t>• State — resolved GUIDs saved to .state.json between steps</a:t>
+            </a:r>
+          </a:p>
+          <a:p>
+            <a:pPr>
+              <a:spcAft>
+                <a:spcPts val="700"/>
+              </a:spcAft>
+            </a:pPr>
+            <a:r>
+              <a:rPr sz="2100">
+                <a:solidFill>
+                  <a:srgbClr val="202020"/>
+                </a:solidFill>
+              </a:rPr>
+              <a:t>• Auth — one az session mints tokens for Fabric and SQL; no extra tooling for procs</a:t>
+            </a:r>
+          </a:p>
+          <a:p>
+            <a:pPr>
+              <a:spcAft>
+                <a:spcPts val="700"/>
+              </a:spcAft>
+            </a:pPr>
+            <a:r>
+              <a:rPr sz="2100">
+                <a:solidFill>
+                  <a:srgbClr val="202020"/>
+                </a:solidFill>
+              </a:rPr>
+              <a:t>• Long-running ops — REST helper polls Operation-Location until Succeeded</a:t>
+            </a:r>
+          </a:p>
+          <a:p>
+            <a:pPr>
+              <a:spcAft>
+                <a:spcPts val="700"/>
+              </a:spcAft>
+            </a:pPr>
+            <a:r>
+              <a:rPr sz="2100">
+                <a:solidFill>
+                  <a:srgbClr val="202020"/>
+                </a:solidFill>
+              </a:rPr>
+              <a:t>• Templated definitions — __TOKENS__ in notebook/pipeline JSON become real GUIDs</a:t>
+            </a:r>
+          </a:p>
+          <a:p>
+            <a:pPr>
+              <a:spcAft>
+                <a:spcPts val="700"/>
+              </a:spcAft>
+            </a:pPr>
+            <a:r>
+              <a:rPr sz="2100">
+                <a:solidFill>
+                  <a:srgbClr val="202020"/>
+                </a:solidFill>
+              </a:rPr>
+              <a:t>• Portable — same definitions deploy into any workspace/tenant</a:t>
+            </a:r>
+          </a:p>
+        </p:txBody>
+      </p:sp>
     </p:spTree>
   </p:cSld>
   <p:clrMapOvr>
@@ -4609,7 +5868,7 @@
         <p:spPr>
           <a:xfrm>
             <a:off x="0" y="0"/>
-            <a:ext cx="12191695" cy="1005840"/>
+            <a:ext cx="12191695" cy="914400"/>
           </a:xfrm>
           <a:prstGeom prst="rect">
             <a:avLst/>
@@ -4652,8 +5911,8 @@
         </p:nvSpPr>
         <p:spPr>
           <a:xfrm>
-            <a:off x="548640" y="164592"/>
-            <a:ext cx="10972800" cy="731520"/>
+            <a:off x="548640" y="109728"/>
+            <a:ext cx="11064240" cy="694944"/>
           </a:xfrm>
           <a:prstGeom prst="rect">
             <a:avLst/>
@@ -4668,12 +5927,12 @@
           <a:p>
             <a:pPr algn="l"/>
             <a:r>
-              <a:rPr sz="3000" b="1">
+              <a:rPr sz="2800" b="1">
                 <a:solidFill>
                   <a:srgbClr val="FFFFFF"/>
                 </a:solidFill>
               </a:rPr>
-              <a:t>Fabric — Notebook</a:t>
+              <a:t>Repeatable across tenants &amp; RGs</a:t>
             </a:r>
           </a:p>
         </p:txBody>
@@ -4686,8 +5945,8 @@
         </p:nvSpPr>
         <p:spPr>
           <a:xfrm>
-            <a:off x="548640" y="1097280"/>
-            <a:ext cx="11064240" cy="548640"/>
+            <a:off x="731520" y="1280160"/>
+            <a:ext cx="10698480" cy="5120640"/>
           </a:xfrm>
           <a:prstGeom prst="rect">
             <a:avLst/>
@@ -4695,47 +5954,87 @@
           <a:noFill/>
         </p:spPr>
         <p:txBody>
-          <a:bodyPr wrap="square" anchor="t">
+          <a:bodyPr wrap="square">
             <a:spAutoFit/>
           </a:bodyPr>
           <a:lstStyle/>
           <a:p>
-            <a:pPr algn="l"/>
-            <a:r>
-              <a:rPr sz="1600" b="0">
-                <a:solidFill>
-                  <a:srgbClr val="555555"/>
+            <a:pPr>
+              <a:spcAft>
+                <a:spcPts val="700"/>
+              </a:spcAft>
+            </a:pPr>
+            <a:r>
+              <a:rPr sz="2100">
+                <a:solidFill>
+                  <a:srgbClr val="202020"/>
                 </a:solidFill>
               </a:rPr>
-              <a:t>nb_demo_load, bound to the Lakehouse, writes the demo dataset with PySpark.</a:t>
-            </a:r>
-          </a:p>
-        </p:txBody>
-      </p:sp>
-      <p:pic>
-        <p:nvPicPr>
-          <p:cNvPr id="5" name="Picture 4" descr="03-notebook.png"/>
-          <p:cNvPicPr>
-            <a:picLocks noChangeAspect="1"/>
-          </p:cNvPicPr>
-          <p:nvPr/>
-        </p:nvPicPr>
-        <p:blipFill>
-          <a:blip r:embed="rId2"/>
-          <a:stretch>
-            <a:fillRect/>
-          </a:stretch>
-        </p:blipFill>
-        <p:spPr>
-          <a:xfrm>
-            <a:off x="548640" y="1828800"/>
-            <a:ext cx="8193511" cy="4480560"/>
-          </a:xfrm>
-          <a:prstGeom prst="rect">
-            <a:avLst/>
-          </a:prstGeom>
-        </p:spPr>
-      </p:pic>
+              <a:t>• All tenant / subscription / secret values live in a git-ignored .env</a:t>
+            </a:r>
+          </a:p>
+          <a:p>
+            <a:pPr>
+              <a:spcAft>
+                <a:spcPts val="700"/>
+              </a:spcAft>
+            </a:pPr>
+            <a:r>
+              <a:rPr sz="2100">
+                <a:solidFill>
+                  <a:srgbClr val="202020"/>
+                </a:solidFill>
+              </a:rPr>
+              <a:t>• Duplicate per environment: .env.dev, .env.customerA, …</a:t>
+            </a:r>
+          </a:p>
+          <a:p>
+            <a:pPr>
+              <a:spcAft>
+                <a:spcPts val="700"/>
+              </a:spcAft>
+            </a:pPr>
+            <a:r>
+              <a:rPr sz="2100">
+                <a:solidFill>
+                  <a:srgbClr val="202020"/>
+                </a:solidFill>
+              </a:rPr>
+              <a:t>• Same scripts, different config → identical environment anywhere</a:t>
+            </a:r>
+          </a:p>
+          <a:p>
+            <a:pPr>
+              <a:spcAft>
+                <a:spcPts val="700"/>
+              </a:spcAft>
+            </a:pPr>
+            <a:r>
+              <a:rPr sz="2100">
+                <a:solidFill>
+                  <a:srgbClr val="202020"/>
+                </a:solidFill>
+              </a:rPr>
+              <a:t>• Service-principal auth for CI/CD and multi-tenant automation</a:t>
+            </a:r>
+          </a:p>
+          <a:p>
+            <a:pPr>
+              <a:spcAft>
+                <a:spcPts val="700"/>
+              </a:spcAft>
+            </a:pPr>
+            <a:r>
+              <a:rPr sz="2100">
+                <a:solidFill>
+                  <a:srgbClr val="202020"/>
+                </a:solidFill>
+              </a:rPr>
+              <a:t>• Public repo: contains no secrets</a:t>
+            </a:r>
+          </a:p>
+        </p:txBody>
+      </p:sp>
     </p:spTree>
   </p:cSld>
   <p:clrMapOvr>
@@ -4763,7 +6062,7 @@
         <p:spPr>
           <a:xfrm>
             <a:off x="0" y="0"/>
-            <a:ext cx="12191695" cy="1005840"/>
+            <a:ext cx="12191695" cy="914400"/>
           </a:xfrm>
           <a:prstGeom prst="rect">
             <a:avLst/>
@@ -4806,8 +6105,8 @@
         </p:nvSpPr>
         <p:spPr>
           <a:xfrm>
-            <a:off x="548640" y="164592"/>
-            <a:ext cx="10972800" cy="731520"/>
+            <a:off x="548640" y="109728"/>
+            <a:ext cx="11064240" cy="694944"/>
           </a:xfrm>
           <a:prstGeom prst="rect">
             <a:avLst/>
@@ -4822,12 +6121,12 @@
           <a:p>
             <a:pPr algn="l"/>
             <a:r>
-              <a:rPr sz="3000" b="1">
+              <a:rPr sz="2800" b="1">
                 <a:solidFill>
                   <a:srgbClr val="FFFFFF"/>
                 </a:solidFill>
               </a:rPr>
-              <a:t>Fabric — Data Pipeline</a:t>
+              <a:t>Fabric — workspace contents</a:t>
             </a:r>
           </a:p>
         </p:txBody>
@@ -4840,8 +6139,8 @@
         </p:nvSpPr>
         <p:spPr>
           <a:xfrm>
-            <a:off x="548640" y="1097280"/>
-            <a:ext cx="11064240" cy="548640"/>
+            <a:off x="548640" y="1024128"/>
+            <a:ext cx="11064240" cy="731520"/>
           </a:xfrm>
           <a:prstGeom prst="rect">
             <a:avLst/>
@@ -4856,19 +6155,19 @@
           <a:p>
             <a:pPr algn="l"/>
             <a:r>
-              <a:rPr sz="1600" b="0">
+              <a:rPr sz="1500" b="0">
                 <a:solidFill>
                   <a:srgbClr val="555555"/>
                 </a:solidFill>
               </a:rPr>
-              <a:t>Wait → Run Notebook (design), and a Succeeded run.</a:t>
+              <a:t>Every item created via the Fabric REST API (Lakehouse + SQL endpoint, Warehouse, Notebook, Pipeline). Created by scripts 03–05.</a:t>
             </a:r>
           </a:p>
         </p:txBody>
       </p:sp>
       <p:pic>
         <p:nvPicPr>
-          <p:cNvPr id="5" name="Picture 4" descr="04-pipeline-canvas.png"/>
+          <p:cNvPr id="5" name="Picture 4" descr="01-workspace-list.png"/>
           <p:cNvPicPr>
             <a:picLocks noChangeAspect="1"/>
           </p:cNvPicPr>
@@ -4882,32 +6181,8 @@
         </p:blipFill>
         <p:spPr>
           <a:xfrm>
-            <a:off x="548640" y="2430770"/>
-            <a:ext cx="5410047" cy="3276620"/>
-          </a:xfrm>
-          <a:prstGeom prst="rect">
-            <a:avLst/>
-          </a:prstGeom>
-        </p:spPr>
-      </p:pic>
-      <p:pic>
-        <p:nvPicPr>
-          <p:cNvPr id="6" name="Picture 5" descr="05-pipeline-run.png"/>
-          <p:cNvPicPr>
-            <a:picLocks noChangeAspect="1"/>
-          </p:cNvPicPr>
-          <p:nvPr/>
-        </p:nvPicPr>
-        <p:blipFill>
-          <a:blip r:embed="rId3"/>
-          <a:stretch>
-            <a:fillRect/>
-          </a:stretch>
-        </p:blipFill>
-        <p:spPr>
-          <a:xfrm>
-            <a:off x="6233007" y="3484842"/>
-            <a:ext cx="5410047" cy="1168476"/>
+            <a:off x="548640" y="2196654"/>
+            <a:ext cx="11094415" cy="3744851"/>
           </a:xfrm>
           <a:prstGeom prst="rect">
             <a:avLst/>
@@ -4941,7 +6216,7 @@
         <p:spPr>
           <a:xfrm>
             <a:off x="0" y="0"/>
-            <a:ext cx="12191695" cy="1005840"/>
+            <a:ext cx="12191695" cy="914400"/>
           </a:xfrm>
           <a:prstGeom prst="rect">
             <a:avLst/>
@@ -4984,8 +6259,8 @@
         </p:nvSpPr>
         <p:spPr>
           <a:xfrm>
-            <a:off x="548640" y="164592"/>
-            <a:ext cx="10972800" cy="731520"/>
+            <a:off x="548640" y="109728"/>
+            <a:ext cx="11064240" cy="694944"/>
           </a:xfrm>
           <a:prstGeom prst="rect">
             <a:avLst/>
@@ -5000,12 +6275,12 @@
           <a:p>
             <a:pPr algn="l"/>
             <a:r>
-              <a:rPr sz="3000" b="1">
+              <a:rPr sz="2800" b="1">
                 <a:solidFill>
                   <a:srgbClr val="FFFFFF"/>
                 </a:solidFill>
               </a:rPr>
-              <a:t>Azure — Fabric capacity</a:t>
+              <a:t>Fabric — Lakehouse with data</a:t>
             </a:r>
           </a:p>
         </p:txBody>
@@ -5018,8 +6293,8 @@
         </p:nvSpPr>
         <p:spPr>
           <a:xfrm>
-            <a:off x="548640" y="1097280"/>
-            <a:ext cx="11064240" cy="548640"/>
+            <a:off x="548640" y="1024128"/>
+            <a:ext cx="11064240" cy="731520"/>
           </a:xfrm>
           <a:prstGeom prst="rect">
             <a:avLst/>
@@ -5034,19 +6309,19 @@
           <a:p>
             <a:pPr algn="l"/>
             <a:r>
-              <a:rPr sz="1600" b="0">
+              <a:rPr sz="1500" b="0">
                 <a:solidFill>
                   <a:srgbClr val="555555"/>
                 </a:solidFill>
               </a:rPr>
-              <a:t>The billable Microsoft.Fabric/capacities resource (F2), deployed by Bicep.</a:t>
+              <a:t>orders_bronze Delta table (5 rows), written by the notebook run — the bronze landing layer. The auto SQL endpoint enables read-only T-SQL / BI.</a:t>
             </a:r>
           </a:p>
         </p:txBody>
       </p:sp>
       <p:pic>
         <p:nvPicPr>
-          <p:cNvPr id="5" name="Picture 4" descr="06-azure-capacity.png"/>
+          <p:cNvPr id="5" name="Picture 4" descr="02-lakehouse-table.png"/>
           <p:cNvPicPr>
             <a:picLocks noChangeAspect="1"/>
           </p:cNvPicPr>
@@ -5060,8 +6335,8 @@
         </p:blipFill>
         <p:spPr>
           <a:xfrm>
-            <a:off x="548640" y="3336686"/>
-            <a:ext cx="11094415" cy="1464788"/>
+            <a:off x="548640" y="2807079"/>
+            <a:ext cx="11094415" cy="2524002"/>
           </a:xfrm>
           <a:prstGeom prst="rect">
             <a:avLst/>

</xml_diff>

<commit_message>
docs+deck: add Terraform option (two ways to deploy, module layout)
</commit_message>
<xml_diff>
--- a/docs/Fabric-as-Code.pptx
+++ b/docs/Fabric-as-Code.pptx
@@ -19,6 +19,8 @@
     <p:sldId id="267" r:id="rId18"/>
     <p:sldId id="268" r:id="rId19"/>
     <p:sldId id="269" r:id="rId20"/>
+    <p:sldId id="270" r:id="rId21"/>
+    <p:sldId id="271" r:id="rId22"/>
   </p:sldIdLst>
   <p:sldSz cx="12191695" cy="6858000" type="screen4x3"/>
   <p:notesSz cx="6858000" cy="9144000"/>
@@ -3338,6 +3340,314 @@
                   <a:srgbClr val="FFFFFF"/>
                 </a:solidFill>
               </a:rPr>
+              <a:t>Fabric — workspace contents</a:t>
+            </a:r>
+          </a:p>
+        </p:txBody>
+      </p:sp>
+      <p:sp>
+        <p:nvSpPr>
+          <p:cNvPr id="4" name="TextBox 3"/>
+          <p:cNvSpPr txBox="1"/>
+          <p:nvPr/>
+        </p:nvSpPr>
+        <p:spPr>
+          <a:xfrm>
+            <a:off x="548640" y="1024128"/>
+            <a:ext cx="11064240" cy="731520"/>
+          </a:xfrm>
+          <a:prstGeom prst="rect">
+            <a:avLst/>
+          </a:prstGeom>
+          <a:noFill/>
+        </p:spPr>
+        <p:txBody>
+          <a:bodyPr wrap="square" anchor="t">
+            <a:spAutoFit/>
+          </a:bodyPr>
+          <a:lstStyle/>
+          <a:p>
+            <a:pPr algn="l"/>
+            <a:r>
+              <a:rPr sz="1500" b="0">
+                <a:solidFill>
+                  <a:srgbClr val="555555"/>
+                </a:solidFill>
+              </a:rPr>
+              <a:t>Every item created via the Fabric REST API (Lakehouse + SQL endpoint, Warehouse, Notebook, Pipeline). Created by scripts 03–05.</a:t>
+            </a:r>
+          </a:p>
+        </p:txBody>
+      </p:sp>
+      <p:pic>
+        <p:nvPicPr>
+          <p:cNvPr id="5" name="Picture 4" descr="01-workspace-list.png"/>
+          <p:cNvPicPr>
+            <a:picLocks noChangeAspect="1"/>
+          </p:cNvPicPr>
+          <p:nvPr/>
+        </p:nvPicPr>
+        <p:blipFill>
+          <a:blip r:embed="rId2"/>
+          <a:stretch>
+            <a:fillRect/>
+          </a:stretch>
+        </p:blipFill>
+        <p:spPr>
+          <a:xfrm>
+            <a:off x="548640" y="2196654"/>
+            <a:ext cx="11094415" cy="3744851"/>
+          </a:xfrm>
+          <a:prstGeom prst="rect">
+            <a:avLst/>
+          </a:prstGeom>
+        </p:spPr>
+      </p:pic>
+    </p:spTree>
+  </p:cSld>
+  <p:clrMapOvr>
+    <a:masterClrMapping/>
+  </p:clrMapOvr>
+</p:sld>
+</file>
+
+<file path=ppt/slides/slide11.xml><?xml version="1.0" encoding="utf-8"?>
+<p:sld xmlns:a="http://schemas.openxmlformats.org/drawingml/2006/main" xmlns:p="http://schemas.openxmlformats.org/presentationml/2006/main" xmlns:r="http://schemas.openxmlformats.org/officeDocument/2006/relationships">
+  <p:cSld>
+    <p:spTree>
+      <p:nvGrpSpPr>
+        <p:cNvPr id="1" name=""/>
+        <p:cNvGrpSpPr/>
+        <p:nvPr/>
+      </p:nvGrpSpPr>
+      <p:grpSpPr/>
+      <p:sp>
+        <p:nvSpPr>
+          <p:cNvPr id="2" name="Rectangle 1"/>
+          <p:cNvSpPr/>
+          <p:nvPr/>
+        </p:nvSpPr>
+        <p:spPr>
+          <a:xfrm>
+            <a:off x="0" y="0"/>
+            <a:ext cx="12191695" cy="914400"/>
+          </a:xfrm>
+          <a:prstGeom prst="rect">
+            <a:avLst/>
+          </a:prstGeom>
+          <a:solidFill>
+            <a:srgbClr val="117365"/>
+          </a:solidFill>
+          <a:ln>
+            <a:noFill/>
+          </a:ln>
+          <a:effectLst/>
+        </p:spPr>
+        <p:style>
+          <a:lnRef idx="1">
+            <a:schemeClr val="accent1"/>
+          </a:lnRef>
+          <a:fillRef idx="3">
+            <a:schemeClr val="accent1"/>
+          </a:fillRef>
+          <a:effectRef idx="2">
+            <a:schemeClr val="accent1"/>
+          </a:effectRef>
+          <a:fontRef idx="minor">
+            <a:schemeClr val="lt1"/>
+          </a:fontRef>
+        </p:style>
+        <p:txBody>
+          <a:bodyPr rtlCol="0" anchor="ctr"/>
+          <a:lstStyle/>
+          <a:p>
+            <a:pPr algn="ctr"/>
+          </a:p>
+        </p:txBody>
+      </p:sp>
+      <p:sp>
+        <p:nvSpPr>
+          <p:cNvPr id="3" name="TextBox 2"/>
+          <p:cNvSpPr txBox="1"/>
+          <p:nvPr/>
+        </p:nvSpPr>
+        <p:spPr>
+          <a:xfrm>
+            <a:off x="548640" y="109728"/>
+            <a:ext cx="11064240" cy="694944"/>
+          </a:xfrm>
+          <a:prstGeom prst="rect">
+            <a:avLst/>
+          </a:prstGeom>
+          <a:noFill/>
+        </p:spPr>
+        <p:txBody>
+          <a:bodyPr wrap="square" anchor="ctr">
+            <a:spAutoFit/>
+          </a:bodyPr>
+          <a:lstStyle/>
+          <a:p>
+            <a:pPr algn="l"/>
+            <a:r>
+              <a:rPr sz="2800" b="1">
+                <a:solidFill>
+                  <a:srgbClr val="FFFFFF"/>
+                </a:solidFill>
+              </a:rPr>
+              <a:t>Fabric — Lakehouse with data</a:t>
+            </a:r>
+          </a:p>
+        </p:txBody>
+      </p:sp>
+      <p:sp>
+        <p:nvSpPr>
+          <p:cNvPr id="4" name="TextBox 3"/>
+          <p:cNvSpPr txBox="1"/>
+          <p:nvPr/>
+        </p:nvSpPr>
+        <p:spPr>
+          <a:xfrm>
+            <a:off x="548640" y="1024128"/>
+            <a:ext cx="11064240" cy="731520"/>
+          </a:xfrm>
+          <a:prstGeom prst="rect">
+            <a:avLst/>
+          </a:prstGeom>
+          <a:noFill/>
+        </p:spPr>
+        <p:txBody>
+          <a:bodyPr wrap="square" anchor="t">
+            <a:spAutoFit/>
+          </a:bodyPr>
+          <a:lstStyle/>
+          <a:p>
+            <a:pPr algn="l"/>
+            <a:r>
+              <a:rPr sz="1500" b="0">
+                <a:solidFill>
+                  <a:srgbClr val="555555"/>
+                </a:solidFill>
+              </a:rPr>
+              <a:t>orders_bronze Delta table (5 rows), written by the notebook run — the bronze landing layer. The auto SQL endpoint enables read-only T-SQL / BI.</a:t>
+            </a:r>
+          </a:p>
+        </p:txBody>
+      </p:sp>
+      <p:pic>
+        <p:nvPicPr>
+          <p:cNvPr id="5" name="Picture 4" descr="02-lakehouse-table.png"/>
+          <p:cNvPicPr>
+            <a:picLocks noChangeAspect="1"/>
+          </p:cNvPicPr>
+          <p:nvPr/>
+        </p:nvPicPr>
+        <p:blipFill>
+          <a:blip r:embed="rId2"/>
+          <a:stretch>
+            <a:fillRect/>
+          </a:stretch>
+        </p:blipFill>
+        <p:spPr>
+          <a:xfrm>
+            <a:off x="548640" y="2807079"/>
+            <a:ext cx="11094415" cy="2524002"/>
+          </a:xfrm>
+          <a:prstGeom prst="rect">
+            <a:avLst/>
+          </a:prstGeom>
+        </p:spPr>
+      </p:pic>
+    </p:spTree>
+  </p:cSld>
+  <p:clrMapOvr>
+    <a:masterClrMapping/>
+  </p:clrMapOvr>
+</p:sld>
+</file>
+
+<file path=ppt/slides/slide12.xml><?xml version="1.0" encoding="utf-8"?>
+<p:sld xmlns:a="http://schemas.openxmlformats.org/drawingml/2006/main" xmlns:p="http://schemas.openxmlformats.org/presentationml/2006/main" xmlns:r="http://schemas.openxmlformats.org/officeDocument/2006/relationships">
+  <p:cSld>
+    <p:spTree>
+      <p:nvGrpSpPr>
+        <p:cNvPr id="1" name=""/>
+        <p:cNvGrpSpPr/>
+        <p:nvPr/>
+      </p:nvGrpSpPr>
+      <p:grpSpPr/>
+      <p:sp>
+        <p:nvSpPr>
+          <p:cNvPr id="2" name="Rectangle 1"/>
+          <p:cNvSpPr/>
+          <p:nvPr/>
+        </p:nvSpPr>
+        <p:spPr>
+          <a:xfrm>
+            <a:off x="0" y="0"/>
+            <a:ext cx="12191695" cy="914400"/>
+          </a:xfrm>
+          <a:prstGeom prst="rect">
+            <a:avLst/>
+          </a:prstGeom>
+          <a:solidFill>
+            <a:srgbClr val="117365"/>
+          </a:solidFill>
+          <a:ln>
+            <a:noFill/>
+          </a:ln>
+          <a:effectLst/>
+        </p:spPr>
+        <p:style>
+          <a:lnRef idx="1">
+            <a:schemeClr val="accent1"/>
+          </a:lnRef>
+          <a:fillRef idx="3">
+            <a:schemeClr val="accent1"/>
+          </a:fillRef>
+          <a:effectRef idx="2">
+            <a:schemeClr val="accent1"/>
+          </a:effectRef>
+          <a:fontRef idx="minor">
+            <a:schemeClr val="lt1"/>
+          </a:fontRef>
+        </p:style>
+        <p:txBody>
+          <a:bodyPr rtlCol="0" anchor="ctr"/>
+          <a:lstStyle/>
+          <a:p>
+            <a:pPr algn="ctr"/>
+          </a:p>
+        </p:txBody>
+      </p:sp>
+      <p:sp>
+        <p:nvSpPr>
+          <p:cNvPr id="3" name="TextBox 2"/>
+          <p:cNvSpPr txBox="1"/>
+          <p:nvPr/>
+        </p:nvSpPr>
+        <p:spPr>
+          <a:xfrm>
+            <a:off x="548640" y="109728"/>
+            <a:ext cx="11064240" cy="694944"/>
+          </a:xfrm>
+          <a:prstGeom prst="rect">
+            <a:avLst/>
+          </a:prstGeom>
+          <a:noFill/>
+        </p:spPr>
+        <p:txBody>
+          <a:bodyPr wrap="square" anchor="ctr">
+            <a:spAutoFit/>
+          </a:bodyPr>
+          <a:lstStyle/>
+          <a:p>
+            <a:pPr algn="l"/>
+            <a:r>
+              <a:rPr sz="2800" b="1">
+                <a:solidFill>
+                  <a:srgbClr val="FFFFFF"/>
+                </a:solidFill>
+              </a:rPr>
               <a:t>Fabric — Notebook</a:t>
             </a:r>
           </a:p>
@@ -3409,7 +3719,7 @@
 </p:sld>
 </file>
 
-<file path=ppt/slides/slide11.xml><?xml version="1.0" encoding="utf-8"?>
+<file path=ppt/slides/slide13.xml><?xml version="1.0" encoding="utf-8"?>
 <p:sld xmlns:a="http://schemas.openxmlformats.org/drawingml/2006/main" xmlns:p="http://schemas.openxmlformats.org/presentationml/2006/main" xmlns:r="http://schemas.openxmlformats.org/officeDocument/2006/relationships">
   <p:cSld>
     <p:spTree>
@@ -3587,7 +3897,7 @@
 </p:sld>
 </file>
 
-<file path=ppt/slides/slide12.xml><?xml version="1.0" encoding="utf-8"?>
+<file path=ppt/slides/slide14.xml><?xml version="1.0" encoding="utf-8"?>
 <p:sld xmlns:a="http://schemas.openxmlformats.org/drawingml/2006/main" xmlns:p="http://schemas.openxmlformats.org/presentationml/2006/main" xmlns:r="http://schemas.openxmlformats.org/officeDocument/2006/relationships">
   <p:cSld>
     <p:spTree>
@@ -3741,7 +4051,7 @@
 </p:sld>
 </file>
 
-<file path=ppt/slides/slide13.xml><?xml version="1.0" encoding="utf-8"?>
+<file path=ppt/slides/slide15.xml><?xml version="1.0" encoding="utf-8"?>
 <p:sld xmlns:a="http://schemas.openxmlformats.org/drawingml/2006/main" xmlns:p="http://schemas.openxmlformats.org/presentationml/2006/main" xmlns:r="http://schemas.openxmlformats.org/officeDocument/2006/relationships">
   <p:cSld>
     <p:spTree>
@@ -3935,7 +4245,7 @@
 </p:sld>
 </file>
 
-<file path=ppt/slides/slide14.xml><?xml version="1.0" encoding="utf-8"?>
+<file path=ppt/slides/slide16.xml><?xml version="1.0" encoding="utf-8"?>
 <p:sld xmlns:a="http://schemas.openxmlformats.org/drawingml/2006/main" xmlns:p="http://schemas.openxmlformats.org/presentationml/2006/main" xmlns:r="http://schemas.openxmlformats.org/officeDocument/2006/relationships">
   <p:cSld>
     <p:spTree>
@@ -6126,69 +6436,428 @@
                   <a:srgbClr val="FFFFFF"/>
                 </a:solidFill>
               </a:rPr>
-              <a:t>Fabric — workspace contents</a:t>
-            </a:r>
-          </a:p>
-        </p:txBody>
-      </p:sp>
-      <p:sp>
-        <p:nvSpPr>
-          <p:cNvPr id="4" name="TextBox 3"/>
-          <p:cNvSpPr txBox="1"/>
+              <a:t>Two ways to deploy</a:t>
+            </a:r>
+          </a:p>
+        </p:txBody>
+      </p:sp>
+      <p:graphicFrame>
+        <p:nvGraphicFramePr>
+          <p:cNvPr id="4" name="Table 3"/>
+          <p:cNvGraphicFramePr>
+            <a:graphicFrameLocks noGrp="1"/>
+          </p:cNvGraphicFramePr>
           <p:nvPr/>
-        </p:nvSpPr>
-        <p:spPr>
-          <a:xfrm>
-            <a:off x="548640" y="1024128"/>
-            <a:ext cx="11064240" cy="731520"/>
-          </a:xfrm>
-          <a:prstGeom prst="rect">
-            <a:avLst/>
-          </a:prstGeom>
-          <a:noFill/>
-        </p:spPr>
-        <p:txBody>
-          <a:bodyPr wrap="square" anchor="t">
-            <a:spAutoFit/>
-          </a:bodyPr>
-          <a:lstStyle/>
-          <a:p>
-            <a:pPr algn="l"/>
-            <a:r>
-              <a:rPr sz="1500" b="0">
-                <a:solidFill>
-                  <a:srgbClr val="555555"/>
-                </a:solidFill>
-              </a:rPr>
-              <a:t>Every item created via the Fabric REST API (Lakehouse + SQL endpoint, Warehouse, Notebook, Pipeline). Created by scripts 03–05.</a:t>
-            </a:r>
-          </a:p>
-        </p:txBody>
-      </p:sp>
-      <p:pic>
-        <p:nvPicPr>
-          <p:cNvPr id="5" name="Picture 4" descr="01-workspace-list.png"/>
-          <p:cNvPicPr>
-            <a:picLocks noChangeAspect="1"/>
-          </p:cNvPicPr>
-          <p:nvPr/>
-        </p:nvPicPr>
-        <p:blipFill>
-          <a:blip r:embed="rId2"/>
-          <a:stretch>
-            <a:fillRect/>
-          </a:stretch>
-        </p:blipFill>
-        <p:spPr>
-          <a:xfrm>
-            <a:off x="548640" y="2196654"/>
-            <a:ext cx="11094415" cy="3744851"/>
-          </a:xfrm>
-          <a:prstGeom prst="rect">
-            <a:avLst/>
-          </a:prstGeom>
-        </p:spPr>
-      </p:pic>
+        </p:nvGraphicFramePr>
+        <p:xfrm>
+          <a:off x="548640" y="1234440"/>
+          <a:ext cx="10698480" cy="5120640"/>
+        </p:xfrm>
+        <a:graphic>
+          <a:graphicData uri="http://schemas.openxmlformats.org/drawingml/2006/table">
+            <a:tbl>
+              <a:tblPr firstRow="1" bandRow="1">
+                <a:tableStyleId>{5C22544A-7EE6-4342-B048-85BDC9FD1C3A}</a:tableStyleId>
+              </a:tblPr>
+              <a:tblGrid>
+                <a:gridCol w="1737360"/>
+                <a:gridCol w="4480560"/>
+                <a:gridCol w="4480560"/>
+              </a:tblGrid>
+              <a:tr h="853440">
+                <a:tc>
+                  <a:txBody>
+                    <a:bodyPr wrap="square"/>
+                    <a:lstStyle/>
+                    <a:p>
+                      <a:r>
+                        <a:rPr b="1" sz="1500">
+                          <a:solidFill>
+                            <a:srgbClr val="FFFFFF"/>
+                          </a:solidFill>
+                        </a:rPr>
+                        <a:t/>
+                      </a:r>
+                    </a:p>
+                  </a:txBody>
+                  <a:tcPr>
+                    <a:solidFill>
+                      <a:srgbClr val="117365"/>
+                    </a:solidFill>
+                  </a:tcPr>
+                </a:tc>
+                <a:tc>
+                  <a:txBody>
+                    <a:bodyPr wrap="square"/>
+                    <a:lstStyle/>
+                    <a:p>
+                      <a:r>
+                        <a:rPr b="1" sz="1500">
+                          <a:solidFill>
+                            <a:srgbClr val="FFFFFF"/>
+                          </a:solidFill>
+                        </a:rPr>
+                        <a:t>Scripts (scripts/)</a:t>
+                      </a:r>
+                    </a:p>
+                  </a:txBody>
+                  <a:tcPr>
+                    <a:solidFill>
+                      <a:srgbClr val="117365"/>
+                    </a:solidFill>
+                  </a:tcPr>
+                </a:tc>
+                <a:tc>
+                  <a:txBody>
+                    <a:bodyPr wrap="square"/>
+                    <a:lstStyle/>
+                    <a:p>
+                      <a:r>
+                        <a:rPr b="1" sz="1500">
+                          <a:solidFill>
+                            <a:srgbClr val="FFFFFF"/>
+                          </a:solidFill>
+                        </a:rPr>
+                        <a:t>Terraform (terraform/)</a:t>
+                      </a:r>
+                    </a:p>
+                  </a:txBody>
+                  <a:tcPr>
+                    <a:solidFill>
+                      <a:srgbClr val="117365"/>
+                    </a:solidFill>
+                  </a:tcPr>
+                </a:tc>
+              </a:tr>
+              <a:tr h="853440">
+                <a:tc>
+                  <a:txBody>
+                    <a:bodyPr wrap="square"/>
+                    <a:lstStyle/>
+                    <a:p>
+                      <a:r>
+                        <a:rPr sz="1300" b="1">
+                          <a:solidFill>
+                            <a:srgbClr val="202020"/>
+                          </a:solidFill>
+                        </a:rPr>
+                        <a:t>Style</a:t>
+                      </a:r>
+                    </a:p>
+                  </a:txBody>
+                  <a:tcPr>
+                    <a:solidFill>
+                      <a:srgbClr val="FFFFFF"/>
+                    </a:solidFill>
+                  </a:tcPr>
+                </a:tc>
+                <a:tc>
+                  <a:txBody>
+                    <a:bodyPr wrap="square"/>
+                    <a:lstStyle/>
+                    <a:p>
+                      <a:r>
+                        <a:rPr sz="1300">
+                          <a:solidFill>
+                            <a:srgbClr val="202020"/>
+                          </a:solidFill>
+                        </a:rPr>
+                        <a:t>Imperative (az CLI + REST)</a:t>
+                      </a:r>
+                    </a:p>
+                  </a:txBody>
+                  <a:tcPr>
+                    <a:solidFill>
+                      <a:srgbClr val="FFFFFF"/>
+                    </a:solidFill>
+                  </a:tcPr>
+                </a:tc>
+                <a:tc>
+                  <a:txBody>
+                    <a:bodyPr wrap="square"/>
+                    <a:lstStyle/>
+                    <a:p>
+                      <a:r>
+                        <a:rPr sz="1300">
+                          <a:solidFill>
+                            <a:srgbClr val="202020"/>
+                          </a:solidFill>
+                        </a:rPr>
+                        <a:t>Declarative + state</a:t>
+                      </a:r>
+                    </a:p>
+                  </a:txBody>
+                  <a:tcPr>
+                    <a:solidFill>
+                      <a:srgbClr val="FFFFFF"/>
+                    </a:solidFill>
+                  </a:tcPr>
+                </a:tc>
+              </a:tr>
+              <a:tr h="853440">
+                <a:tc>
+                  <a:txBody>
+                    <a:bodyPr wrap="square"/>
+                    <a:lstStyle/>
+                    <a:p>
+                      <a:r>
+                        <a:rPr sz="1300" b="1">
+                          <a:solidFill>
+                            <a:srgbClr val="202020"/>
+                          </a:solidFill>
+                        </a:rPr>
+                        <a:t>Capacity</a:t>
+                      </a:r>
+                    </a:p>
+                  </a:txBody>
+                  <a:tcPr>
+                    <a:solidFill>
+                      <a:srgbClr val="E3F1EE"/>
+                    </a:solidFill>
+                  </a:tcPr>
+                </a:tc>
+                <a:tc>
+                  <a:txBody>
+                    <a:bodyPr wrap="square"/>
+                    <a:lstStyle/>
+                    <a:p>
+                      <a:r>
+                        <a:rPr sz="1300">
+                          <a:solidFill>
+                            <a:srgbClr val="202020"/>
+                          </a:solidFill>
+                        </a:rPr>
+                        <a:t>Bicep</a:t>
+                      </a:r>
+                    </a:p>
+                  </a:txBody>
+                  <a:tcPr>
+                    <a:solidFill>
+                      <a:srgbClr val="E3F1EE"/>
+                    </a:solidFill>
+                  </a:tcPr>
+                </a:tc>
+                <a:tc>
+                  <a:txBody>
+                    <a:bodyPr wrap="square"/>
+                    <a:lstStyle/>
+                    <a:p>
+                      <a:r>
+                        <a:rPr sz="1300">
+                          <a:solidFill>
+                            <a:srgbClr val="202020"/>
+                          </a:solidFill>
+                        </a:rPr>
+                        <a:t>azurerm_fabric_capacity</a:t>
+                      </a:r>
+                    </a:p>
+                  </a:txBody>
+                  <a:tcPr>
+                    <a:solidFill>
+                      <a:srgbClr val="E3F1EE"/>
+                    </a:solidFill>
+                  </a:tcPr>
+                </a:tc>
+              </a:tr>
+              <a:tr h="853440">
+                <a:tc>
+                  <a:txBody>
+                    <a:bodyPr wrap="square"/>
+                    <a:lstStyle/>
+                    <a:p>
+                      <a:r>
+                        <a:rPr sz="1300" b="1">
+                          <a:solidFill>
+                            <a:srgbClr val="202020"/>
+                          </a:solidFill>
+                        </a:rPr>
+                        <a:t>Items</a:t>
+                      </a:r>
+                    </a:p>
+                  </a:txBody>
+                  <a:tcPr>
+                    <a:solidFill>
+                      <a:srgbClr val="FFFFFF"/>
+                    </a:solidFill>
+                  </a:tcPr>
+                </a:tc>
+                <a:tc>
+                  <a:txBody>
+                    <a:bodyPr wrap="square"/>
+                    <a:lstStyle/>
+                    <a:p>
+                      <a:r>
+                        <a:rPr sz="1300">
+                          <a:solidFill>
+                            <a:srgbClr val="202020"/>
+                          </a:solidFill>
+                        </a:rPr>
+                        <a:t>Fabric REST</a:t>
+                      </a:r>
+                    </a:p>
+                  </a:txBody>
+                  <a:tcPr>
+                    <a:solidFill>
+                      <a:srgbClr val="FFFFFF"/>
+                    </a:solidFill>
+                  </a:tcPr>
+                </a:tc>
+                <a:tc>
+                  <a:txBody>
+                    <a:bodyPr wrap="square"/>
+                    <a:lstStyle/>
+                    <a:p>
+                      <a:r>
+                        <a:rPr sz="1300">
+                          <a:solidFill>
+                            <a:srgbClr val="202020"/>
+                          </a:solidFill>
+                        </a:rPr>
+                        <a:t>microsoft/fabric provider</a:t>
+                      </a:r>
+                    </a:p>
+                  </a:txBody>
+                  <a:tcPr>
+                    <a:solidFill>
+                      <a:srgbClr val="FFFFFF"/>
+                    </a:solidFill>
+                  </a:tcPr>
+                </a:tc>
+              </a:tr>
+              <a:tr h="853440">
+                <a:tc>
+                  <a:txBody>
+                    <a:bodyPr wrap="square"/>
+                    <a:lstStyle/>
+                    <a:p>
+                      <a:r>
+                        <a:rPr sz="1300" b="1">
+                          <a:solidFill>
+                            <a:srgbClr val="202020"/>
+                          </a:solidFill>
+                        </a:rPr>
+                        <a:t>State</a:t>
+                      </a:r>
+                    </a:p>
+                  </a:txBody>
+                  <a:tcPr>
+                    <a:solidFill>
+                      <a:srgbClr val="E3F1EE"/>
+                    </a:solidFill>
+                  </a:tcPr>
+                </a:tc>
+                <a:tc>
+                  <a:txBody>
+                    <a:bodyPr wrap="square"/>
+                    <a:lstStyle/>
+                    <a:p>
+                      <a:r>
+                        <a:rPr sz="1300">
+                          <a:solidFill>
+                            <a:srgbClr val="202020"/>
+                          </a:solidFill>
+                        </a:rPr>
+                        <a:t>.state.json</a:t>
+                      </a:r>
+                    </a:p>
+                  </a:txBody>
+                  <a:tcPr>
+                    <a:solidFill>
+                      <a:srgbClr val="E3F1EE"/>
+                    </a:solidFill>
+                  </a:tcPr>
+                </a:tc>
+                <a:tc>
+                  <a:txBody>
+                    <a:bodyPr wrap="square"/>
+                    <a:lstStyle/>
+                    <a:p>
+                      <a:r>
+                        <a:rPr sz="1300">
+                          <a:solidFill>
+                            <a:srgbClr val="202020"/>
+                          </a:solidFill>
+                        </a:rPr>
+                        <a:t>Terraform state</a:t>
+                      </a:r>
+                    </a:p>
+                  </a:txBody>
+                  <a:tcPr>
+                    <a:solidFill>
+                      <a:srgbClr val="E3F1EE"/>
+                    </a:solidFill>
+                  </a:tcPr>
+                </a:tc>
+              </a:tr>
+              <a:tr h="853440">
+                <a:tc>
+                  <a:txBody>
+                    <a:bodyPr wrap="square"/>
+                    <a:lstStyle/>
+                    <a:p>
+                      <a:r>
+                        <a:rPr sz="1300" b="1">
+                          <a:solidFill>
+                            <a:srgbClr val="202020"/>
+                          </a:solidFill>
+                        </a:rPr>
+                        <a:t>Stored procs</a:t>
+                      </a:r>
+                    </a:p>
+                  </a:txBody>
+                  <a:tcPr>
+                    <a:solidFill>
+                      <a:srgbClr val="FFFFFF"/>
+                    </a:solidFill>
+                  </a:tcPr>
+                </a:tc>
+                <a:tc>
+                  <a:txBody>
+                    <a:bodyPr wrap="square"/>
+                    <a:lstStyle/>
+                    <a:p>
+                      <a:r>
+                        <a:rPr sz="1300">
+                          <a:solidFill>
+                            <a:srgbClr val="202020"/>
+                          </a:solidFill>
+                        </a:rPr>
+                        <a:t>T-SQL via SqlClient</a:t>
+                      </a:r>
+                    </a:p>
+                  </a:txBody>
+                  <a:tcPr>
+                    <a:solidFill>
+                      <a:srgbClr val="FFFFFF"/>
+                    </a:solidFill>
+                  </a:tcPr>
+                </a:tc>
+                <a:tc>
+                  <a:txBody>
+                    <a:bodyPr wrap="square"/>
+                    <a:lstStyle/>
+                    <a:p>
+                      <a:r>
+                        <a:rPr sz="1300">
+                          <a:solidFill>
+                            <a:srgbClr val="202020"/>
+                          </a:solidFill>
+                        </a:rPr>
+                        <a:t>same script via null_resource</a:t>
+                      </a:r>
+                    </a:p>
+                  </a:txBody>
+                  <a:tcPr>
+                    <a:solidFill>
+                      <a:srgbClr val="FFFFFF"/>
+                    </a:solidFill>
+                  </a:tcPr>
+                </a:tc>
+              </a:tr>
+            </a:tbl>
+          </a:graphicData>
+        </a:graphic>
+      </p:graphicFrame>
     </p:spTree>
   </p:cSld>
   <p:clrMapOvr>
@@ -6280,7 +6949,7 @@
                   <a:srgbClr val="FFFFFF"/>
                 </a:solidFill>
               </a:rPr>
-              <a:t>Fabric — Lakehouse with data</a:t>
+              <a:t>Terraform module layout</a:t>
             </a:r>
           </a:p>
         </p:txBody>
@@ -6293,8 +6962,8 @@
         </p:nvSpPr>
         <p:spPr>
           <a:xfrm>
-            <a:off x="548640" y="1024128"/>
-            <a:ext cx="11064240" cy="731520"/>
+            <a:off x="731520" y="1280160"/>
+            <a:ext cx="10698480" cy="5120640"/>
           </a:xfrm>
           <a:prstGeom prst="rect">
             <a:avLst/>
@@ -6302,47 +6971,117 @@
           <a:noFill/>
         </p:spPr>
         <p:txBody>
-          <a:bodyPr wrap="square" anchor="t">
+          <a:bodyPr wrap="square">
             <a:spAutoFit/>
           </a:bodyPr>
           <a:lstStyle/>
           <a:p>
-            <a:pPr algn="l"/>
-            <a:r>
-              <a:rPr sz="1500" b="0">
+            <a:pPr>
+              <a:spcAft>
+                <a:spcPts val="700"/>
+              </a:spcAft>
+            </a:pPr>
+            <a:r>
+              <a:rPr sz="2100">
+                <a:solidFill>
+                  <a:srgbClr val="202020"/>
+                </a:solidFill>
+              </a:rPr>
+              <a:t>• terraform/modules/capacity — azurerm_fabric_capacity + capacity GUID lookup</a:t>
+            </a:r>
+          </a:p>
+          <a:p>
+            <a:pPr>
+              <a:spcAft>
+                <a:spcPts val="700"/>
+              </a:spcAft>
+            </a:pPr>
+            <a:r>
+              <a:rPr sz="2100">
+                <a:solidFill>
+                  <a:srgbClr val="202020"/>
+                </a:solidFill>
+              </a:rPr>
+              <a:t>• terraform/modules/workspace — fabric_workspace, bound to the capacity</a:t>
+            </a:r>
+          </a:p>
+          <a:p>
+            <a:pPr>
+              <a:spcAft>
+                <a:spcPts val="700"/>
+              </a:spcAft>
+            </a:pPr>
+            <a:r>
+              <a:rPr sz="2100">
+                <a:solidFill>
+                  <a:srgbClr val="202020"/>
+                </a:solidFill>
+              </a:rPr>
+              <a:t>• terraform/modules/items — lakehouse, warehouse, notebook, data_pipeline</a:t>
+            </a:r>
+          </a:p>
+          <a:p>
+            <a:pPr>
+              <a:spcAft>
+                <a:spcPts val="700"/>
+              </a:spcAft>
+            </a:pPr>
+            <a:r>
+              <a:rPr sz="2100">
+                <a:solidFill>
+                  <a:srgbClr val="202020"/>
+                </a:solidFill>
+              </a:rPr>
+              <a:t>• terraform/modules/sql — null_resource -&gt; deploy-procs.ps1 (stored procs)</a:t>
+            </a:r>
+          </a:p>
+          <a:p>
+            <a:pPr lvl="1">
+              <a:spcAft>
+                <a:spcPts val="700"/>
+              </a:spcAft>
+            </a:pPr>
+            <a:r>
+              <a:rPr sz="1700">
                 <a:solidFill>
                   <a:srgbClr val="555555"/>
                 </a:solidFill>
               </a:rPr>
-              <a:t>orders_bronze Delta table (5 rows), written by the notebook run — the bronze landing layer. The auto SQL endpoint enables read-only T-SQL / BI.</a:t>
-            </a:r>
-          </a:p>
-        </p:txBody>
-      </p:sp>
-      <p:pic>
-        <p:nvPicPr>
-          <p:cNvPr id="5" name="Picture 4" descr="02-lakehouse-table.png"/>
-          <p:cNvPicPr>
-            <a:picLocks noChangeAspect="1"/>
-          </p:cNvPicPr>
-          <p:nvPr/>
-        </p:nvPicPr>
-        <p:blipFill>
-          <a:blip r:embed="rId2"/>
-          <a:stretch>
-            <a:fillRect/>
-          </a:stretch>
-        </p:blipFill>
-        <p:spPr>
-          <a:xfrm>
-            <a:off x="548640" y="2807079"/>
-            <a:ext cx="11094415" cy="2524002"/>
-          </a:xfrm>
-          <a:prstGeom prst="rect">
-            <a:avLst/>
-          </a:prstGeom>
-        </p:spPr>
-      </p:pic>
+              <a:t>– Items reuse the same __TOKEN__ definition files via provider TextReplace</a:t>
+            </a:r>
+          </a:p>
+          <a:p>
+            <a:pPr lvl="1">
+              <a:spcAft>
+                <a:spcPts val="700"/>
+              </a:spcAft>
+            </a:pPr>
+            <a:r>
+              <a:rPr sz="1700">
+                <a:solidFill>
+                  <a:srgbClr val="555555"/>
+                </a:solidFill>
+              </a:rPr>
+              <a:t>– Verified end-to-end with a real apply/destroy (8 resources)</a:t>
+            </a:r>
+          </a:p>
+          <a:p>
+            <a:pPr>
+              <a:spcAft>
+                <a:spcPts val="700"/>
+              </a:spcAft>
+            </a:pPr>
+            <a:r>
+              <a:rPr sz="2100">
+                <a:solidFill>
+                  <a:srgbClr val="202020"/>
+                </a:solidFill>
+              </a:rPr>
+              <a:t>• Run: terraform init &amp;&amp; terraform plan &amp;&amp; terraform apply</a:t>
+            </a:r>
+          </a:p>
+        </p:txBody>
+      </p:sp>
     </p:spTree>
   </p:cSld>
   <p:clrMapOvr>

</xml_diff>